<commit_message>
Rework demo deck: visual-first slides, detailed content moved to speaker notes
</commit_message>
<xml_diff>
--- a/DEMO_new.pptx
+++ b/DEMO_new.pptx
@@ -116,6 +116,1196 @@
     </a:lvl9pPr>
   </p:defaultTextStyle>
 </p:presentation>
+</file>
+
+<file path=ppt/notesMasters/notesMaster1.xml><?xml version="1.0" encoding="utf-8"?>
+<p:notesMaster xmlns:a="http://schemas.openxmlformats.org/drawingml/2006/main" xmlns:p="http://schemas.openxmlformats.org/presentationml/2006/main" xmlns:r="http://schemas.openxmlformats.org/officeDocument/2006/relationships">
+  <p:cSld>
+    <p:bg>
+      <p:bgRef idx="1001">
+        <a:schemeClr val="bg1"/>
+      </p:bgRef>
+    </p:bg>
+    <p:spTree>
+      <p:nvGrpSpPr>
+        <p:cNvPr id="1" name=""/>
+        <p:cNvGrpSpPr/>
+        <p:nvPr/>
+      </p:nvGrpSpPr>
+      <p:grpSpPr>
+        <a:xfrm>
+          <a:off x="0" y="0"/>
+          <a:ext cx="0" cy="0"/>
+          <a:chOff x="0" y="0"/>
+          <a:chExt cx="0" cy="0"/>
+        </a:xfrm>
+      </p:grpSpPr>
+      <p:sp>
+        <p:nvSpPr>
+          <p:cNvPr id="2" name="Header Placeholder 1"/>
+          <p:cNvSpPr>
+            <a:spLocks noGrp="1"/>
+          </p:cNvSpPr>
+          <p:nvPr>
+            <p:ph type="hdr" sz="quarter"/>
+          </p:nvPr>
+        </p:nvSpPr>
+        <p:spPr>
+          <a:xfrm>
+            <a:off x="0" y="0"/>
+            <a:ext cx="2971800" cy="457200"/>
+          </a:xfrm>
+          <a:prstGeom prst="rect">
+            <a:avLst/>
+          </a:prstGeom>
+        </p:spPr>
+        <p:txBody>
+          <a:bodyPr vert="horz" lIns="91440" tIns="45720" rIns="91440" bIns="45720" rtlCol="0"/>
+          <a:lstStyle>
+            <a:lvl1pPr algn="l">
+              <a:defRPr sz="1200"/>
+            </a:lvl1pPr>
+          </a:lstStyle>
+          <a:p>
+            <a:endParaRPr lang="en-US"/>
+          </a:p>
+        </p:txBody>
+      </p:sp>
+      <p:sp>
+        <p:nvSpPr>
+          <p:cNvPr id="3" name="Date Placeholder 2"/>
+          <p:cNvSpPr>
+            <a:spLocks noGrp="1"/>
+          </p:cNvSpPr>
+          <p:nvPr>
+            <p:ph type="dt" idx="1"/>
+          </p:nvPr>
+        </p:nvSpPr>
+        <p:spPr>
+          <a:xfrm>
+            <a:off x="3884613" y="0"/>
+            <a:ext cx="2971800" cy="457200"/>
+          </a:xfrm>
+          <a:prstGeom prst="rect">
+            <a:avLst/>
+          </a:prstGeom>
+        </p:spPr>
+        <p:txBody>
+          <a:bodyPr vert="horz" lIns="91440" tIns="45720" rIns="91440" bIns="45720" rtlCol="0"/>
+          <a:lstStyle>
+            <a:lvl1pPr algn="r">
+              <a:defRPr sz="1200"/>
+            </a:lvl1pPr>
+          </a:lstStyle>
+          <a:p>
+            <a:fld id="{0F89C1C7-3DCD-1040-A9CF-14679D8B5DDD}" type="datetimeFigureOut">
+              <a:rPr lang="en-US" smtClean="0"/>
+              <a:t>10/17/16</a:t>
+            </a:fld>
+            <a:endParaRPr lang="en-US"/>
+          </a:p>
+        </p:txBody>
+      </p:sp>
+      <p:sp>
+        <p:nvSpPr>
+          <p:cNvPr id="4" name="Slide Image Placeholder 3"/>
+          <p:cNvSpPr>
+            <a:spLocks noGrp="1" noRot="1" noChangeAspect="1"/>
+          </p:cNvSpPr>
+          <p:nvPr>
+            <p:ph type="sldImg" idx="2"/>
+          </p:nvPr>
+        </p:nvSpPr>
+        <p:spPr>
+          <a:xfrm>
+            <a:off x="1143000" y="685800"/>
+            <a:ext cx="4572000" cy="3429000"/>
+          </a:xfrm>
+          <a:prstGeom prst="rect">
+            <a:avLst/>
+          </a:prstGeom>
+          <a:noFill/>
+          <a:ln w="12700">
+            <a:solidFill>
+              <a:prstClr val="black"/>
+            </a:solidFill>
+          </a:ln>
+        </p:spPr>
+        <p:txBody>
+          <a:bodyPr vert="horz" lIns="91440" tIns="45720" rIns="91440" bIns="45720" rtlCol="0" anchor="ctr"/>
+          <a:lstStyle/>
+          <a:p>
+            <a:endParaRPr lang="en-US"/>
+          </a:p>
+        </p:txBody>
+      </p:sp>
+      <p:sp>
+        <p:nvSpPr>
+          <p:cNvPr id="5" name="Notes Placeholder 4"/>
+          <p:cNvSpPr>
+            <a:spLocks noGrp="1"/>
+          </p:cNvSpPr>
+          <p:nvPr>
+            <p:ph type="body" sz="quarter" idx="3"/>
+          </p:nvPr>
+        </p:nvSpPr>
+        <p:spPr>
+          <a:xfrm>
+            <a:off x="685800" y="4343400"/>
+            <a:ext cx="5486400" cy="4114800"/>
+          </a:xfrm>
+          <a:prstGeom prst="rect">
+            <a:avLst/>
+          </a:prstGeom>
+        </p:spPr>
+        <p:txBody>
+          <a:bodyPr vert="horz" lIns="91440" tIns="45720" rIns="91440" bIns="45720" rtlCol="0"/>
+          <a:lstStyle/>
+          <a:p>
+            <a:pPr lvl="0"/>
+            <a:r>
+              <a:rPr lang="en-US" smtClean="0"/>
+              <a:t>Click to edit Master text styles</a:t>
+            </a:r>
+          </a:p>
+          <a:p>
+            <a:pPr lvl="1"/>
+            <a:r>
+              <a:rPr lang="en-US" smtClean="0"/>
+              <a:t>Second level</a:t>
+            </a:r>
+          </a:p>
+          <a:p>
+            <a:pPr lvl="2"/>
+            <a:r>
+              <a:rPr lang="en-US" smtClean="0"/>
+              <a:t>Third level</a:t>
+            </a:r>
+          </a:p>
+          <a:p>
+            <a:pPr lvl="3"/>
+            <a:r>
+              <a:rPr lang="en-US" smtClean="0"/>
+              <a:t>Fourth level</a:t>
+            </a:r>
+          </a:p>
+          <a:p>
+            <a:pPr lvl="4"/>
+            <a:r>
+              <a:rPr lang="en-US" smtClean="0"/>
+              <a:t>Fifth level</a:t>
+            </a:r>
+            <a:endParaRPr lang="en-US"/>
+          </a:p>
+        </p:txBody>
+      </p:sp>
+      <p:sp>
+        <p:nvSpPr>
+          <p:cNvPr id="6" name="Footer Placeholder 5"/>
+          <p:cNvSpPr>
+            <a:spLocks noGrp="1"/>
+          </p:cNvSpPr>
+          <p:nvPr>
+            <p:ph type="ftr" sz="quarter" idx="4"/>
+          </p:nvPr>
+        </p:nvSpPr>
+        <p:spPr>
+          <a:xfrm>
+            <a:off x="0" y="8685213"/>
+            <a:ext cx="2971800" cy="457200"/>
+          </a:xfrm>
+          <a:prstGeom prst="rect">
+            <a:avLst/>
+          </a:prstGeom>
+        </p:spPr>
+        <p:txBody>
+          <a:bodyPr vert="horz" lIns="91440" tIns="45720" rIns="91440" bIns="45720" rtlCol="0" anchor="b"/>
+          <a:lstStyle>
+            <a:lvl1pPr algn="l">
+              <a:defRPr sz="1200"/>
+            </a:lvl1pPr>
+          </a:lstStyle>
+          <a:p>
+            <a:endParaRPr lang="en-US"/>
+          </a:p>
+        </p:txBody>
+      </p:sp>
+      <p:sp>
+        <p:nvSpPr>
+          <p:cNvPr id="7" name="Slide Number Placeholder 6"/>
+          <p:cNvSpPr>
+            <a:spLocks noGrp="1"/>
+          </p:cNvSpPr>
+          <p:nvPr>
+            <p:ph type="sldNum" sz="quarter" idx="5"/>
+          </p:nvPr>
+        </p:nvSpPr>
+        <p:spPr>
+          <a:xfrm>
+            <a:off x="3884613" y="8685213"/>
+            <a:ext cx="2971800" cy="457200"/>
+          </a:xfrm>
+          <a:prstGeom prst="rect">
+            <a:avLst/>
+          </a:prstGeom>
+        </p:spPr>
+        <p:txBody>
+          <a:bodyPr vert="horz" lIns="91440" tIns="45720" rIns="91440" bIns="45720" rtlCol="0" anchor="b"/>
+          <a:lstStyle>
+            <a:lvl1pPr algn="r">
+              <a:defRPr sz="1200"/>
+            </a:lvl1pPr>
+          </a:lstStyle>
+          <a:p>
+            <a:fld id="{BB5E49A5-4136-284D-997B-48E1D791AD67}" type="slidenum">
+              <a:rPr lang="en-US" smtClean="0"/>
+              <a:t>‹#›</a:t>
+            </a:fld>
+            <a:endParaRPr lang="en-US"/>
+          </a:p>
+        </p:txBody>
+      </p:sp>
+    </p:spTree>
+    <p:extLst>
+      <p:ext uri="{BB962C8B-B14F-4D97-AF65-F5344CB8AC3E}">
+        <p14:creationId xmlns:p14="http://schemas.microsoft.com/office/powerpoint/2010/main" val="2623252185"/>
+      </p:ext>
+    </p:extLst>
+  </p:cSld>
+  <p:clrMap bg1="lt1" tx1="dk1" bg2="lt2" tx2="dk2" accent1="accent1" accent2="accent2" accent3="accent3" accent4="accent4" accent5="accent5" accent6="accent6" hlink="hlink" folHlink="folHlink"/>
+  <p:notesStyle>
+    <a:lvl1pPr marL="0" algn="l" defTabSz="457200" rtl="0" eaLnBrk="1" latinLnBrk="0" hangingPunct="1">
+      <a:defRPr sz="1200" kern="1200">
+        <a:solidFill>
+          <a:schemeClr val="tx1"/>
+        </a:solidFill>
+        <a:latin typeface="+mn-lt"/>
+        <a:ea typeface="+mn-ea"/>
+        <a:cs typeface="+mn-cs"/>
+      </a:defRPr>
+    </a:lvl1pPr>
+    <a:lvl2pPr marL="457200" algn="l" defTabSz="457200" rtl="0" eaLnBrk="1" latinLnBrk="0" hangingPunct="1">
+      <a:defRPr sz="1200" kern="1200">
+        <a:solidFill>
+          <a:schemeClr val="tx1"/>
+        </a:solidFill>
+        <a:latin typeface="+mn-lt"/>
+        <a:ea typeface="+mn-ea"/>
+        <a:cs typeface="+mn-cs"/>
+      </a:defRPr>
+    </a:lvl2pPr>
+    <a:lvl3pPr marL="914400" algn="l" defTabSz="457200" rtl="0" eaLnBrk="1" latinLnBrk="0" hangingPunct="1">
+      <a:defRPr sz="1200" kern="1200">
+        <a:solidFill>
+          <a:schemeClr val="tx1"/>
+        </a:solidFill>
+        <a:latin typeface="+mn-lt"/>
+        <a:ea typeface="+mn-ea"/>
+        <a:cs typeface="+mn-cs"/>
+      </a:defRPr>
+    </a:lvl3pPr>
+    <a:lvl4pPr marL="1371600" algn="l" defTabSz="457200" rtl="0" eaLnBrk="1" latinLnBrk="0" hangingPunct="1">
+      <a:defRPr sz="1200" kern="1200">
+        <a:solidFill>
+          <a:schemeClr val="tx1"/>
+        </a:solidFill>
+        <a:latin typeface="+mn-lt"/>
+        <a:ea typeface="+mn-ea"/>
+        <a:cs typeface="+mn-cs"/>
+      </a:defRPr>
+    </a:lvl4pPr>
+    <a:lvl5pPr marL="1828800" algn="l" defTabSz="457200" rtl="0" eaLnBrk="1" latinLnBrk="0" hangingPunct="1">
+      <a:defRPr sz="1200" kern="1200">
+        <a:solidFill>
+          <a:schemeClr val="tx1"/>
+        </a:solidFill>
+        <a:latin typeface="+mn-lt"/>
+        <a:ea typeface="+mn-ea"/>
+        <a:cs typeface="+mn-cs"/>
+      </a:defRPr>
+    </a:lvl5pPr>
+    <a:lvl6pPr marL="2286000" algn="l" defTabSz="457200" rtl="0" eaLnBrk="1" latinLnBrk="0" hangingPunct="1">
+      <a:defRPr sz="1200" kern="1200">
+        <a:solidFill>
+          <a:schemeClr val="tx1"/>
+        </a:solidFill>
+        <a:latin typeface="+mn-lt"/>
+        <a:ea typeface="+mn-ea"/>
+        <a:cs typeface="+mn-cs"/>
+      </a:defRPr>
+    </a:lvl6pPr>
+    <a:lvl7pPr marL="2743200" algn="l" defTabSz="457200" rtl="0" eaLnBrk="1" latinLnBrk="0" hangingPunct="1">
+      <a:defRPr sz="1200" kern="1200">
+        <a:solidFill>
+          <a:schemeClr val="tx1"/>
+        </a:solidFill>
+        <a:latin typeface="+mn-lt"/>
+        <a:ea typeface="+mn-ea"/>
+        <a:cs typeface="+mn-cs"/>
+      </a:defRPr>
+    </a:lvl7pPr>
+    <a:lvl8pPr marL="3200400" algn="l" defTabSz="457200" rtl="0" eaLnBrk="1" latinLnBrk="0" hangingPunct="1">
+      <a:defRPr sz="1200" kern="1200">
+        <a:solidFill>
+          <a:schemeClr val="tx1"/>
+        </a:solidFill>
+        <a:latin typeface="+mn-lt"/>
+        <a:ea typeface="+mn-ea"/>
+        <a:cs typeface="+mn-cs"/>
+      </a:defRPr>
+    </a:lvl8pPr>
+    <a:lvl9pPr marL="3657600" algn="l" defTabSz="457200" rtl="0" eaLnBrk="1" latinLnBrk="0" hangingPunct="1">
+      <a:defRPr sz="1200" kern="1200">
+        <a:solidFill>
+          <a:schemeClr val="tx1"/>
+        </a:solidFill>
+        <a:latin typeface="+mn-lt"/>
+        <a:ea typeface="+mn-ea"/>
+        <a:cs typeface="+mn-cs"/>
+      </a:defRPr>
+    </a:lvl9pPr>
+  </p:notesStyle>
+</p:notesMaster>
+</file>
+
+<file path=ppt/notesSlides/notesSlide1.xml><?xml version="1.0" encoding="utf-8"?>
+<p:notes xmlns:a="http://schemas.openxmlformats.org/drawingml/2006/main" xmlns:p="http://schemas.openxmlformats.org/presentationml/2006/main" xmlns:r="http://schemas.openxmlformats.org/officeDocument/2006/relationships">
+  <p:cSld>
+    <p:spTree>
+      <p:nvGrpSpPr>
+        <p:cNvPr id="1" name=""/>
+        <p:cNvGrpSpPr/>
+        <p:nvPr/>
+      </p:nvGrpSpPr>
+      <p:grpSpPr>
+        <a:xfrm>
+          <a:off x="0" y="0"/>
+          <a:ext cx="0" cy="0"/>
+          <a:chOff x="0" y="0"/>
+          <a:chExt cx="0" cy="0"/>
+        </a:xfrm>
+      </p:grpSpPr>
+      <p:sp>
+        <p:nvSpPr>
+          <p:cNvPr id="2" name="Slide Image Placeholder 1"/>
+          <p:cNvSpPr>
+            <a:spLocks noGrp="1"/>
+          </p:cNvSpPr>
+          <p:nvPr>
+            <p:ph type="sldImg" idx="2"/>
+          </p:nvPr>
+        </p:nvSpPr>
+        <p:spPr/>
+      </p:sp>
+      <p:sp>
+        <p:nvSpPr>
+          <p:cNvPr id="3" name="Notes Placeholder 2"/>
+          <p:cNvSpPr>
+            <a:spLocks noGrp="1"/>
+          </p:cNvSpPr>
+          <p:nvPr>
+            <p:ph type="body" idx="3" sz="quarter"/>
+          </p:nvPr>
+        </p:nvSpPr>
+        <p:spPr/>
+        <p:txBody>
+          <a:bodyPr/>
+          <a:lstStyle/>
+          <a:p>
+            <a:r>
+              <a:t>Intro. I'm an intern, and this is a proof-of-concept tool I built that auto-generates a first-draft annotated CRF (aCRF) from a blank CRF PDF. It does the repetitive ~80% of the annotation work; the SDTM programmer then reviews and finalises. I'm framing it as a helpful first draft and a starting point — not a replacement for our existing process.</a:t>
+            </a:r>
+          </a:p>
+        </p:txBody>
+      </p:sp>
+      <p:sp>
+        <p:nvSpPr>
+          <p:cNvPr id="4" name="Slide Number Placeholder 3"/>
+          <p:cNvSpPr>
+            <a:spLocks noGrp="1"/>
+          </p:cNvSpPr>
+          <p:nvPr>
+            <p:ph type="sldNum" idx="5" sz="quarter"/>
+          </p:nvPr>
+        </p:nvSpPr>
+        <p:spPr/>
+      </p:sp>
+    </p:spTree>
+  </p:cSld>
+  <p:clrMapOvr>
+    <a:masterClrMapping/>
+  </p:clrMapOvr>
+</p:notes>
+</file>
+
+<file path=ppt/notesSlides/notesSlide10.xml><?xml version="1.0" encoding="utf-8"?>
+<p:notes xmlns:a="http://schemas.openxmlformats.org/drawingml/2006/main" xmlns:p="http://schemas.openxmlformats.org/presentationml/2006/main" xmlns:r="http://schemas.openxmlformats.org/officeDocument/2006/relationships">
+  <p:cSld>
+    <p:spTree>
+      <p:nvGrpSpPr>
+        <p:cNvPr id="1" name=""/>
+        <p:cNvGrpSpPr/>
+        <p:nvPr/>
+      </p:nvGrpSpPr>
+      <p:grpSpPr>
+        <a:xfrm>
+          <a:off x="0" y="0"/>
+          <a:ext cx="0" cy="0"/>
+          <a:chOff x="0" y="0"/>
+          <a:chExt cx="0" cy="0"/>
+        </a:xfrm>
+      </p:grpSpPr>
+      <p:sp>
+        <p:nvSpPr>
+          <p:cNvPr id="2" name="Slide Image Placeholder 1"/>
+          <p:cNvSpPr>
+            <a:spLocks noGrp="1"/>
+          </p:cNvSpPr>
+          <p:nvPr>
+            <p:ph type="sldImg" idx="2"/>
+          </p:nvPr>
+        </p:nvSpPr>
+        <p:spPr/>
+      </p:sp>
+      <p:sp>
+        <p:nvSpPr>
+          <p:cNvPr id="3" name="Notes Placeholder 2"/>
+          <p:cNvSpPr>
+            <a:spLocks noGrp="1"/>
+          </p:cNvSpPr>
+          <p:nvPr>
+            <p:ph type="body" idx="3" sz="quarter"/>
+          </p:nvPr>
+        </p:nvSpPr>
+        <p:spPr/>
+        <p:txBody>
+          <a:bodyPr/>
+          <a:lstStyle/>
+          <a:p>
+            <a:r>
+              <a:t>First-draft coverage across 4 different CRFs and export styles: 87% (D9186, standard), 62% and 62% (UAT builds with codes stripped out), and 90% (D5180, 503 pages). Strongest domains: DM, VS, LB, EG, AE, CM, MH, IE, SV. Being honest, the harder cases are novel field wording, complex skip-logic forms, study-specific questionnaires, and per-test grid fan-out.</a:t>
+            </a:r>
+          </a:p>
+        </p:txBody>
+      </p:sp>
+      <p:sp>
+        <p:nvSpPr>
+          <p:cNvPr id="4" name="Slide Number Placeholder 3"/>
+          <p:cNvSpPr>
+            <a:spLocks noGrp="1"/>
+          </p:cNvSpPr>
+          <p:nvPr>
+            <p:ph type="sldNum" idx="5" sz="quarter"/>
+          </p:nvPr>
+        </p:nvSpPr>
+        <p:spPr/>
+      </p:sp>
+    </p:spTree>
+  </p:cSld>
+  <p:clrMapOvr>
+    <a:masterClrMapping/>
+  </p:clrMapOvr>
+</p:notes>
+</file>
+
+<file path=ppt/notesSlides/notesSlide11.xml><?xml version="1.0" encoding="utf-8"?>
+<p:notes xmlns:a="http://schemas.openxmlformats.org/drawingml/2006/main" xmlns:p="http://schemas.openxmlformats.org/presentationml/2006/main" xmlns:r="http://schemas.openxmlformats.org/officeDocument/2006/relationships">
+  <p:cSld>
+    <p:spTree>
+      <p:nvGrpSpPr>
+        <p:cNvPr id="1" name=""/>
+        <p:cNvGrpSpPr/>
+        <p:nvPr/>
+      </p:nvGrpSpPr>
+      <p:grpSpPr>
+        <a:xfrm>
+          <a:off x="0" y="0"/>
+          <a:ext cx="0" cy="0"/>
+          <a:chOff x="0" y="0"/>
+          <a:chExt cx="0" cy="0"/>
+        </a:xfrm>
+      </p:grpSpPr>
+      <p:sp>
+        <p:nvSpPr>
+          <p:cNvPr id="2" name="Slide Image Placeholder 1"/>
+          <p:cNvSpPr>
+            <a:spLocks noGrp="1"/>
+          </p:cNvSpPr>
+          <p:nvPr>
+            <p:ph type="sldImg" idx="2"/>
+          </p:nvPr>
+        </p:nvSpPr>
+        <p:spPr/>
+      </p:sp>
+      <p:sp>
+        <p:nvSpPr>
+          <p:cNvPr id="3" name="Notes Placeholder 2"/>
+          <p:cNvSpPr>
+            <a:spLocks noGrp="1"/>
+          </p:cNvSpPr>
+          <p:nvPr>
+            <p:ph type="body" idx="3" sz="quarter"/>
+          </p:nvPr>
+        </p:nvSpPr>
+        <p:spPr/>
+        <p:txBody>
+          <a:bodyPr/>
+          <a:lstStyle/>
+          <a:p>
+            <a:r>
+              <a:t>The highest-leverage next step is an AI assist as a Tier-3 fallback for the ~10% hard tail. It would run only on unresolved or low-confidence fields, see the field label plus form context plus candidate variables, and propose a mapping with a confidence score — never overriding high-confidence mappings. Assist-only keeps the trustworthy core and adds reach on the long tail. Also on the roadmap: per-test grid fan-out and growing the knowledge library (config only, no code change). Human review is always in the loop.</a:t>
+            </a:r>
+          </a:p>
+        </p:txBody>
+      </p:sp>
+      <p:sp>
+        <p:nvSpPr>
+          <p:cNvPr id="4" name="Slide Number Placeholder 3"/>
+          <p:cNvSpPr>
+            <a:spLocks noGrp="1"/>
+          </p:cNvSpPr>
+          <p:nvPr>
+            <p:ph type="sldNum" idx="5" sz="quarter"/>
+          </p:nvPr>
+        </p:nvSpPr>
+        <p:spPr/>
+      </p:sp>
+    </p:spTree>
+  </p:cSld>
+  <p:clrMapOvr>
+    <a:masterClrMapping/>
+  </p:clrMapOvr>
+</p:notes>
+</file>
+
+<file path=ppt/notesSlides/notesSlide12.xml><?xml version="1.0" encoding="utf-8"?>
+<p:notes xmlns:a="http://schemas.openxmlformats.org/drawingml/2006/main" xmlns:p="http://schemas.openxmlformats.org/presentationml/2006/main" xmlns:r="http://schemas.openxmlformats.org/officeDocument/2006/relationships">
+  <p:cSld>
+    <p:spTree>
+      <p:nvGrpSpPr>
+        <p:cNvPr id="1" name=""/>
+        <p:cNvGrpSpPr/>
+        <p:nvPr/>
+      </p:nvGrpSpPr>
+      <p:grpSpPr>
+        <a:xfrm>
+          <a:off x="0" y="0"/>
+          <a:ext cx="0" cy="0"/>
+          <a:chOff x="0" y="0"/>
+          <a:chExt cx="0" cy="0"/>
+        </a:xfrm>
+      </p:grpSpPr>
+      <p:sp>
+        <p:nvSpPr>
+          <p:cNvPr id="2" name="Slide Image Placeholder 1"/>
+          <p:cNvSpPr>
+            <a:spLocks noGrp="1"/>
+          </p:cNvSpPr>
+          <p:nvPr>
+            <p:ph type="sldImg" idx="2"/>
+          </p:nvPr>
+        </p:nvSpPr>
+        <p:spPr/>
+      </p:sp>
+      <p:sp>
+        <p:nvSpPr>
+          <p:cNvPr id="3" name="Notes Placeholder 2"/>
+          <p:cNvSpPr>
+            <a:spLocks noGrp="1"/>
+          </p:cNvSpPr>
+          <p:nvPr>
+            <p:ph type="body" idx="3" sz="quarter"/>
+          </p:nvPr>
+        </p:nvSpPr>
+        <p:spPr/>
+        <p:txBody>
+          <a:bodyPr/>
+          <a:lstStyle/>
+          <a:p>
+            <a:r>
+              <a:t>To recap: it automates the repetitive ~80% and leaves judgement to the expert; it's explainable and transparent — every annotation is traceable; it's validation-friendly — searchable, Pinnacle-21 ready, editable both ways; it generalises across EDC export styles, tested on 4 CRFs; and it's a first draft and a starting point, not a replacement for review. Thank you — happy to take questions.</a:t>
+            </a:r>
+          </a:p>
+        </p:txBody>
+      </p:sp>
+      <p:sp>
+        <p:nvSpPr>
+          <p:cNvPr id="4" name="Slide Number Placeholder 3"/>
+          <p:cNvSpPr>
+            <a:spLocks noGrp="1"/>
+          </p:cNvSpPr>
+          <p:nvPr>
+            <p:ph type="sldNum" idx="5" sz="quarter"/>
+          </p:nvPr>
+        </p:nvSpPr>
+        <p:spPr/>
+      </p:sp>
+    </p:spTree>
+  </p:cSld>
+  <p:clrMapOvr>
+    <a:masterClrMapping/>
+  </p:clrMapOvr>
+</p:notes>
+</file>
+
+<file path=ppt/notesSlides/notesSlide2.xml><?xml version="1.0" encoding="utf-8"?>
+<p:notes xmlns:a="http://schemas.openxmlformats.org/drawingml/2006/main" xmlns:p="http://schemas.openxmlformats.org/presentationml/2006/main" xmlns:r="http://schemas.openxmlformats.org/officeDocument/2006/relationships">
+  <p:cSld>
+    <p:spTree>
+      <p:nvGrpSpPr>
+        <p:cNvPr id="1" name=""/>
+        <p:cNvGrpSpPr/>
+        <p:nvPr/>
+      </p:nvGrpSpPr>
+      <p:grpSpPr>
+        <a:xfrm>
+          <a:off x="0" y="0"/>
+          <a:ext cx="0" cy="0"/>
+          <a:chOff x="0" y="0"/>
+          <a:chExt cx="0" cy="0"/>
+        </a:xfrm>
+      </p:grpSpPr>
+      <p:sp>
+        <p:nvSpPr>
+          <p:cNvPr id="2" name="Slide Image Placeholder 1"/>
+          <p:cNvSpPr>
+            <a:spLocks noGrp="1"/>
+          </p:cNvSpPr>
+          <p:nvPr>
+            <p:ph type="sldImg" idx="2"/>
+          </p:nvPr>
+        </p:nvSpPr>
+        <p:spPr/>
+      </p:sp>
+      <p:sp>
+        <p:nvSpPr>
+          <p:cNvPr id="3" name="Notes Placeholder 2"/>
+          <p:cNvSpPr>
+            <a:spLocks noGrp="1"/>
+          </p:cNvSpPr>
+          <p:nvPr>
+            <p:ph type="body" idx="3" sz="quarter"/>
+          </p:nvPr>
+        </p:nvSpPr>
+        <p:spPr/>
+        <p:txBody>
+          <a:bodyPr/>
+          <a:lstStyle/>
+          <a:p>
+            <a:r>
+              <a:t>Every study ships a blank CRF of roughly 500 pages that has to be annotated by hand to SDTM. It's slow (days to weeks of specialist effort per study), repetitive (the same common DM / VS / LB / AE / CM mappings are redone every study), and being manual it's easy to be inconsistent across pages and reviewers. The first ~80% is mechanical; the hard ~20% needs real judgement. The opportunity is to auto-generate the mechanical first draft and free experts for the hard part.</a:t>
+            </a:r>
+          </a:p>
+        </p:txBody>
+      </p:sp>
+      <p:sp>
+        <p:nvSpPr>
+          <p:cNvPr id="4" name="Slide Number Placeholder 3"/>
+          <p:cNvSpPr>
+            <a:spLocks noGrp="1"/>
+          </p:cNvSpPr>
+          <p:nvPr>
+            <p:ph type="sldNum" idx="5" sz="quarter"/>
+          </p:nvPr>
+        </p:nvSpPr>
+        <p:spPr/>
+      </p:sp>
+    </p:spTree>
+  </p:cSld>
+  <p:clrMapOvr>
+    <a:masterClrMapping/>
+  </p:clrMapOvr>
+</p:notes>
+</file>
+
+<file path=ppt/notesSlides/notesSlide3.xml><?xml version="1.0" encoding="utf-8"?>
+<p:notes xmlns:a="http://schemas.openxmlformats.org/drawingml/2006/main" xmlns:p="http://schemas.openxmlformats.org/presentationml/2006/main" xmlns:r="http://schemas.openxmlformats.org/officeDocument/2006/relationships">
+  <p:cSld>
+    <p:spTree>
+      <p:nvGrpSpPr>
+        <p:cNvPr id="1" name=""/>
+        <p:cNvGrpSpPr/>
+        <p:nvPr/>
+      </p:nvGrpSpPr>
+      <p:grpSpPr>
+        <a:xfrm>
+          <a:off x="0" y="0"/>
+          <a:ext cx="0" cy="0"/>
+          <a:chOff x="0" y="0"/>
+          <a:chExt cx="0" cy="0"/>
+        </a:xfrm>
+      </p:grpSpPr>
+      <p:sp>
+        <p:nvSpPr>
+          <p:cNvPr id="2" name="Slide Image Placeholder 1"/>
+          <p:cNvSpPr>
+            <a:spLocks noGrp="1"/>
+          </p:cNvSpPr>
+          <p:nvPr>
+            <p:ph type="sldImg" idx="2"/>
+          </p:nvPr>
+        </p:nvSpPr>
+        <p:spPr/>
+      </p:sp>
+      <p:sp>
+        <p:nvSpPr>
+          <p:cNvPr id="3" name="Notes Placeholder 2"/>
+          <p:cNvSpPr>
+            <a:spLocks noGrp="1"/>
+          </p:cNvSpPr>
+          <p:nvPr>
+            <p:ph type="body" idx="3" sz="quarter"/>
+          </p:nvPr>
+        </p:nvSpPr>
+        <p:spPr/>
+        <p:txBody>
+          <a:bodyPr/>
+          <a:lstStyle/>
+          <a:p>
+            <a:r>
+              <a:t>Input: a blank CRF PDF (an AstraZeneca EDC export). Output, in seconds: a first-draft annotated CRF PDF — the SDTM DOMAIN.VARIABLE placed in the right margin beside each field, colour-coded by domain class, with dual bookmarks and a colour legend page. Every mapping is explainable. Honest scope: this is a reviewed first draft, not a validated final aCRF.</a:t>
+            </a:r>
+          </a:p>
+        </p:txBody>
+      </p:sp>
+      <p:sp>
+        <p:nvSpPr>
+          <p:cNvPr id="4" name="Slide Number Placeholder 3"/>
+          <p:cNvSpPr>
+            <a:spLocks noGrp="1"/>
+          </p:cNvSpPr>
+          <p:nvPr>
+            <p:ph type="sldNum" idx="5" sz="quarter"/>
+          </p:nvPr>
+        </p:nvSpPr>
+        <p:spPr/>
+      </p:sp>
+    </p:spTree>
+  </p:cSld>
+  <p:clrMapOvr>
+    <a:masterClrMapping/>
+  </p:clrMapOvr>
+</p:notes>
+</file>
+
+<file path=ppt/notesSlides/notesSlide4.xml><?xml version="1.0" encoding="utf-8"?>
+<p:notes xmlns:a="http://schemas.openxmlformats.org/drawingml/2006/main" xmlns:p="http://schemas.openxmlformats.org/presentationml/2006/main" xmlns:r="http://schemas.openxmlformats.org/officeDocument/2006/relationships">
+  <p:cSld>
+    <p:spTree>
+      <p:nvGrpSpPr>
+        <p:cNvPr id="1" name=""/>
+        <p:cNvGrpSpPr/>
+        <p:nvPr/>
+      </p:nvGrpSpPr>
+      <p:grpSpPr>
+        <a:xfrm>
+          <a:off x="0" y="0"/>
+          <a:ext cx="0" cy="0"/>
+          <a:chOff x="0" y="0"/>
+          <a:chExt cx="0" cy="0"/>
+        </a:xfrm>
+      </p:grpSpPr>
+      <p:sp>
+        <p:nvSpPr>
+          <p:cNvPr id="2" name="Slide Image Placeholder 1"/>
+          <p:cNvSpPr>
+            <a:spLocks noGrp="1"/>
+          </p:cNvSpPr>
+          <p:nvPr>
+            <p:ph type="sldImg" idx="2"/>
+          </p:nvPr>
+        </p:nvSpPr>
+        <p:spPr/>
+      </p:sp>
+      <p:sp>
+        <p:nvSpPr>
+          <p:cNvPr id="3" name="Notes Placeholder 2"/>
+          <p:cNvSpPr>
+            <a:spLocks noGrp="1"/>
+          </p:cNvSpPr>
+          <p:nvPr>
+            <p:ph type="body" idx="3" sz="quarter"/>
+          </p:nvPr>
+        </p:nvSpPr>
+        <p:spPr/>
+        <p:txBody>
+          <a:bodyPr/>
+          <a:lstStyle/>
+          <a:p>
+            <a:r>
+              <a:t>The pipeline: read the blank CRF, locate every field (geometry-aware — it works even when the EDC prints no field numbers), map each field to SDTM, then annotate and bookmark. The annotations are written as real, searchable PDF text objects.</a:t>
+            </a:r>
+          </a:p>
+        </p:txBody>
+      </p:sp>
+      <p:sp>
+        <p:nvSpPr>
+          <p:cNvPr id="4" name="Slide Number Placeholder 3"/>
+          <p:cNvSpPr>
+            <a:spLocks noGrp="1"/>
+          </p:cNvSpPr>
+          <p:nvPr>
+            <p:ph type="sldNum" idx="5" sz="quarter"/>
+          </p:nvPr>
+        </p:nvSpPr>
+        <p:spPr/>
+      </p:sp>
+    </p:spTree>
+  </p:cSld>
+  <p:clrMapOvr>
+    <a:masterClrMapping/>
+  </p:clrMapOvr>
+</p:notes>
+</file>
+
+<file path=ppt/notesSlides/notesSlide5.xml><?xml version="1.0" encoding="utf-8"?>
+<p:notes xmlns:a="http://schemas.openxmlformats.org/drawingml/2006/main" xmlns:p="http://schemas.openxmlformats.org/presentationml/2006/main" xmlns:r="http://schemas.openxmlformats.org/officeDocument/2006/relationships">
+  <p:cSld>
+    <p:spTree>
+      <p:nvGrpSpPr>
+        <p:cNvPr id="1" name=""/>
+        <p:cNvGrpSpPr/>
+        <p:nvPr/>
+      </p:nvGrpSpPr>
+      <p:grpSpPr>
+        <a:xfrm>
+          <a:off x="0" y="0"/>
+          <a:ext cx="0" cy="0"/>
+          <a:chOff x="0" y="0"/>
+          <a:chExt cx="0" cy="0"/>
+        </a:xfrm>
+      </p:grpSpPr>
+      <p:sp>
+        <p:nvSpPr>
+          <p:cNvPr id="2" name="Slide Image Placeholder 1"/>
+          <p:cNvSpPr>
+            <a:spLocks noGrp="1"/>
+          </p:cNvSpPr>
+          <p:nvPr>
+            <p:ph type="sldImg" idx="2"/>
+          </p:nvPr>
+        </p:nvSpPr>
+        <p:spPr/>
+      </p:sp>
+      <p:sp>
+        <p:nvSpPr>
+          <p:cNvPr id="3" name="Notes Placeholder 2"/>
+          <p:cNvSpPr>
+            <a:spLocks noGrp="1"/>
+          </p:cNvSpPr>
+          <p:nvPr>
+            <p:ph type="body" idx="3" sz="quarter"/>
+          </p:nvPr>
+        </p:nvSpPr>
+        <p:spPr/>
+        <p:txBody>
+          <a:bodyPr/>
+          <a:lstStyle/>
+          <a:p>
+            <a:r>
+              <a:t>Each field passes through confidence-ranked layers and the highest-confidence match wins. First a pre-filter skips derived and coded fields. Then: AZ + CDISC curated knowledge (highest confidence, ~0.98), CDISC SDTM standards match (~0.92), study-spec exact label match (~0.90), and study-spec similarity match (&lt;=0.86). High-confidence matches are never overridden. Because the later layers use CDISC standards and similarity, a brand-new CRF still gets meaningful coverage. MedDRA / WHO-Drug / ATC coded fields are skipped before mapping. Everything is auditable and reproducible — which matters for GxP.</a:t>
+            </a:r>
+          </a:p>
+        </p:txBody>
+      </p:sp>
+      <p:sp>
+        <p:nvSpPr>
+          <p:cNvPr id="4" name="Slide Number Placeholder 3"/>
+          <p:cNvSpPr>
+            <a:spLocks noGrp="1"/>
+          </p:cNvSpPr>
+          <p:nvPr>
+            <p:ph type="sldNum" idx="5" sz="quarter"/>
+          </p:nvPr>
+        </p:nvSpPr>
+        <p:spPr/>
+      </p:sp>
+    </p:spTree>
+  </p:cSld>
+  <p:clrMapOvr>
+    <a:masterClrMapping/>
+  </p:clrMapOvr>
+</p:notes>
+</file>
+
+<file path=ppt/notesSlides/notesSlide6.xml><?xml version="1.0" encoding="utf-8"?>
+<p:notes xmlns:a="http://schemas.openxmlformats.org/drawingml/2006/main" xmlns:p="http://schemas.openxmlformats.org/presentationml/2006/main" xmlns:r="http://schemas.openxmlformats.org/officeDocument/2006/relationships">
+  <p:cSld>
+    <p:spTree>
+      <p:nvGrpSpPr>
+        <p:cNvPr id="1" name=""/>
+        <p:cNvGrpSpPr/>
+        <p:nvPr/>
+      </p:nvGrpSpPr>
+      <p:grpSpPr>
+        <a:xfrm>
+          <a:off x="0" y="0"/>
+          <a:ext cx="0" cy="0"/>
+          <a:chOff x="0" y="0"/>
+          <a:chExt cx="0" cy="0"/>
+        </a:xfrm>
+      </p:grpSpPr>
+      <p:sp>
+        <p:nvSpPr>
+          <p:cNvPr id="2" name="Slide Image Placeholder 1"/>
+          <p:cNvSpPr>
+            <a:spLocks noGrp="1"/>
+          </p:cNvSpPr>
+          <p:nvPr>
+            <p:ph type="sldImg" idx="2"/>
+          </p:nvPr>
+        </p:nvSpPr>
+        <p:spPr/>
+      </p:sp>
+      <p:sp>
+        <p:nvSpPr>
+          <p:cNvPr id="3" name="Notes Placeholder 2"/>
+          <p:cNvSpPr>
+            <a:spLocks noGrp="1"/>
+          </p:cNvSpPr>
+          <p:nvPr>
+            <p:ph type="body" idx="3" sz="quarter"/>
+          </p:nvPr>
+        </p:nvSpPr>
+        <p:spPr/>
+        <p:txBody>
+          <a:bodyPr/>
+          <a:lstStyle/>
+          <a:p>
+            <a:r>
+              <a:t>We follow CDISC aCRF conventions. Every collected field gets DOMAIN.VARIABLE, or [NOT SUBMITTED] if it's collected but unmapped. Derived and coded fields — MedDRA, WHO-Drug, ATC dictionary terms — are skipped entirely; their traceability lives in Define-XML. Verbatim free-text is annotated (AE.AETERM, CM.CMTRT...) while its coded partner is skipped. Format: ALL CAPS, codelist in (Cxxxxx), SUPP--.QVAL where QNAM, and value-level where-clauses. Colour by domain class, dual bookmarks (by visit and by topic), searchable text, and a legend page. The [NOT SUBMITTED] list is editable business logic, not a fixed spec, so it's easy to extend.</a:t>
+            </a:r>
+          </a:p>
+        </p:txBody>
+      </p:sp>
+      <p:sp>
+        <p:nvSpPr>
+          <p:cNvPr id="4" name="Slide Number Placeholder 3"/>
+          <p:cNvSpPr>
+            <a:spLocks noGrp="1"/>
+          </p:cNvSpPr>
+          <p:nvPr>
+            <p:ph type="sldNum" idx="5" sz="quarter"/>
+          </p:nvPr>
+        </p:nvSpPr>
+        <p:spPr/>
+      </p:sp>
+    </p:spTree>
+  </p:cSld>
+  <p:clrMapOvr>
+    <a:masterClrMapping/>
+  </p:clrMapOvr>
+</p:notes>
+</file>
+
+<file path=ppt/notesSlides/notesSlide7.xml><?xml version="1.0" encoding="utf-8"?>
+<p:notes xmlns:a="http://schemas.openxmlformats.org/drawingml/2006/main" xmlns:p="http://schemas.openxmlformats.org/presentationml/2006/main" xmlns:r="http://schemas.openxmlformats.org/officeDocument/2006/relationships">
+  <p:cSld>
+    <p:spTree>
+      <p:nvGrpSpPr>
+        <p:cNvPr id="1" name=""/>
+        <p:cNvGrpSpPr/>
+        <p:nvPr/>
+      </p:nvGrpSpPr>
+      <p:grpSpPr>
+        <a:xfrm>
+          <a:off x="0" y="0"/>
+          <a:ext cx="0" cy="0"/>
+          <a:chOff x="0" y="0"/>
+          <a:chExt cx="0" cy="0"/>
+        </a:xfrm>
+      </p:grpSpPr>
+      <p:sp>
+        <p:nvSpPr>
+          <p:cNvPr id="2" name="Slide Image Placeholder 1"/>
+          <p:cNvSpPr>
+            <a:spLocks noGrp="1"/>
+          </p:cNvSpPr>
+          <p:nvPr>
+            <p:ph type="sldImg" idx="2"/>
+          </p:nvPr>
+        </p:nvSpPr>
+        <p:spPr/>
+      </p:sp>
+      <p:sp>
+        <p:nvSpPr>
+          <p:cNvPr id="3" name="Notes Placeholder 2"/>
+          <p:cNvSpPr>
+            <a:spLocks noGrp="1"/>
+          </p:cNvSpPr>
+          <p:nvPr>
+            <p:ph type="body" idx="3" sz="quarter"/>
+          </p:nvPr>
+        </p:nvSpPr>
+        <p:spPr/>
+        <p:txBody>
+          <a:bodyPr/>
+          <a:lstStyle/>
+          <a:p>
+            <a:r>
+              <a:t>These are real generated pages, not mockups. Left: Demographics — DM.SEX / DM.RACE / DM.ETHNIC, plus SUPPDM.QVAL for 'other race, specify'. Right: a Findings page — VS.VSORRES with value-level 'where VSTESTCD = ...' per test. This shows annotations placed next to the field, carrying the correct qualifiers.</a:t>
+            </a:r>
+          </a:p>
+        </p:txBody>
+      </p:sp>
+      <p:sp>
+        <p:nvSpPr>
+          <p:cNvPr id="4" name="Slide Number Placeholder 3"/>
+          <p:cNvSpPr>
+            <a:spLocks noGrp="1"/>
+          </p:cNvSpPr>
+          <p:nvPr>
+            <p:ph type="sldNum" idx="5" sz="quarter"/>
+          </p:nvPr>
+        </p:nvSpPr>
+        <p:spPr/>
+      </p:sp>
+    </p:spTree>
+  </p:cSld>
+  <p:clrMapOvr>
+    <a:masterClrMapping/>
+  </p:clrMapOvr>
+</p:notes>
+</file>
+
+<file path=ppt/notesSlides/notesSlide8.xml><?xml version="1.0" encoding="utf-8"?>
+<p:notes xmlns:a="http://schemas.openxmlformats.org/drawingml/2006/main" xmlns:p="http://schemas.openxmlformats.org/presentationml/2006/main" xmlns:r="http://schemas.openxmlformats.org/officeDocument/2006/relationships">
+  <p:cSld>
+    <p:spTree>
+      <p:nvGrpSpPr>
+        <p:cNvPr id="1" name=""/>
+        <p:cNvGrpSpPr/>
+        <p:nvPr/>
+      </p:nvGrpSpPr>
+      <p:grpSpPr>
+        <a:xfrm>
+          <a:off x="0" y="0"/>
+          <a:ext cx="0" cy="0"/>
+          <a:chOff x="0" y="0"/>
+          <a:chExt cx="0" cy="0"/>
+        </a:xfrm>
+      </p:grpSpPr>
+      <p:sp>
+        <p:nvSpPr>
+          <p:cNvPr id="2" name="Slide Image Placeholder 1"/>
+          <p:cNvSpPr>
+            <a:spLocks noGrp="1"/>
+          </p:cNvSpPr>
+          <p:nvPr>
+            <p:ph type="sldImg" idx="2"/>
+          </p:nvPr>
+        </p:nvSpPr>
+        <p:spPr/>
+      </p:sp>
+      <p:sp>
+        <p:nvSpPr>
+          <p:cNvPr id="3" name="Notes Placeholder 2"/>
+          <p:cNvSpPr>
+            <a:spLocks noGrp="1"/>
+          </p:cNvSpPr>
+          <p:nvPr>
+            <p:ph type="body" idx="3" sz="quarter"/>
+          </p:nvPr>
+        </p:nvSpPr>
+        <p:spPr/>
+        <p:txBody>
+          <a:bodyPr/>
+          <a:lstStyle/>
+          <a:p>
+            <a:r>
+              <a:t>The annotations are real PDF text objects, not flattened images — so they're searchable (Ctrl+F), selectable, and extractable by Pinnacle 21, the industry-standard aCRF validation tool. They're editable both ways: in the review frontend (edit a mapping and regenerate) and directly in the output PDF (e.g. Adobe), exactly like a hand-annotated aCRF. So it drops into the existing QC / validation workflow with no friction.</a:t>
+            </a:r>
+          </a:p>
+        </p:txBody>
+      </p:sp>
+      <p:sp>
+        <p:nvSpPr>
+          <p:cNvPr id="4" name="Slide Number Placeholder 3"/>
+          <p:cNvSpPr>
+            <a:spLocks noGrp="1"/>
+          </p:cNvSpPr>
+          <p:nvPr>
+            <p:ph type="sldNum" idx="5" sz="quarter"/>
+          </p:nvPr>
+        </p:nvSpPr>
+        <p:spPr/>
+      </p:sp>
+    </p:spTree>
+  </p:cSld>
+  <p:clrMapOvr>
+    <a:masterClrMapping/>
+  </p:clrMapOvr>
+</p:notes>
+</file>
+
+<file path=ppt/notesSlides/notesSlide9.xml><?xml version="1.0" encoding="utf-8"?>
+<p:notes xmlns:a="http://schemas.openxmlformats.org/drawingml/2006/main" xmlns:p="http://schemas.openxmlformats.org/presentationml/2006/main" xmlns:r="http://schemas.openxmlformats.org/officeDocument/2006/relationships">
+  <p:cSld>
+    <p:spTree>
+      <p:nvGrpSpPr>
+        <p:cNvPr id="1" name=""/>
+        <p:cNvGrpSpPr/>
+        <p:nvPr/>
+      </p:nvGrpSpPr>
+      <p:grpSpPr>
+        <a:xfrm>
+          <a:off x="0" y="0"/>
+          <a:ext cx="0" cy="0"/>
+          <a:chOff x="0" y="0"/>
+          <a:chExt cx="0" cy="0"/>
+        </a:xfrm>
+      </p:grpSpPr>
+      <p:sp>
+        <p:nvSpPr>
+          <p:cNvPr id="2" name="Slide Image Placeholder 1"/>
+          <p:cNvSpPr>
+            <a:spLocks noGrp="1"/>
+          </p:cNvSpPr>
+          <p:nvPr>
+            <p:ph type="sldImg" idx="2"/>
+          </p:nvPr>
+        </p:nvSpPr>
+        <p:spPr/>
+      </p:sp>
+      <p:sp>
+        <p:nvSpPr>
+          <p:cNvPr id="3" name="Notes Placeholder 2"/>
+          <p:cNvSpPr>
+            <a:spLocks noGrp="1"/>
+          </p:cNvSpPr>
+          <p:nvPr>
+            <p:ph type="body" idx="3" sz="quarter"/>
+          </p:nvPr>
+        </p:nvSpPr>
+        <p:spPr/>
+        <p:txBody>
+          <a:bodyPr/>
+          <a:lstStyle/>
+          <a:p>
+            <a:r>
+              <a:t>Built CRF-first and study-agnostic. It handles 4+ study-ID header formats plus a 'Project Name:' fallback for UAT/preview builds, recovers a form code from the form name when the EDC omits it (30+ patterns), and infers the domain from codes, suffixes (VS1), underscores (LB_HEM) and variants (DEM to DM). Important distinction: any CRF flows into this tool, but a tool hard-wired to one EDC's export format would not generalise back to arbitrary CRFs. Tested on 4 different blank CRFs, not just one.</a:t>
+            </a:r>
+          </a:p>
+        </p:txBody>
+      </p:sp>
+      <p:sp>
+        <p:nvSpPr>
+          <p:cNvPr id="4" name="Slide Number Placeholder 3"/>
+          <p:cNvSpPr>
+            <a:spLocks noGrp="1"/>
+          </p:cNvSpPr>
+          <p:nvPr>
+            <p:ph type="sldNum" idx="5" sz="quarter"/>
+          </p:nvPr>
+        </p:nvSpPr>
+        <p:spPr/>
+      </p:sp>
+    </p:spTree>
+  </p:cSld>
+  <p:clrMapOvr>
+    <a:masterClrMapping/>
+  </p:clrMapOvr>
+</p:notes>
 </file>
 
 <file path=ppt/slideLayouts/slideLayout1.xml><?xml version="1.0" encoding="utf-8"?>
@@ -3428,134 +4618,6 @@
       </p:pic>
       <p:sp>
         <p:nvSpPr>
-          <p:cNvPr id="5" name="TextBox 4"/>
-          <p:cNvSpPr txBox="1"/>
-          <p:nvPr/>
-        </p:nvSpPr>
-        <p:spPr>
-          <a:xfrm>
-            <a:off x="7315200" y="1371600"/>
-            <a:ext cx="4480560" cy="4937760"/>
-          </a:xfrm>
-          <a:prstGeom prst="rect">
-            <a:avLst/>
-          </a:prstGeom>
-          <a:noFill/>
-        </p:spPr>
-        <p:txBody>
-          <a:bodyPr wrap="square">
-            <a:spAutoFit/>
-          </a:bodyPr>
-          <a:lstStyle/>
-          <a:p>
-            <a:pPr>
-              <a:spcAft>
-                <a:spcPts val="700"/>
-              </a:spcAft>
-              <a:defRPr sz="1300" b="1">
-                <a:solidFill>
-                  <a:srgbClr val="1F3A5F"/>
-                </a:solidFill>
-              </a:defRPr>
-            </a:pPr>
-            <a:r>
-              <a:t>•  Strongest domains</a:t>
-            </a:r>
-          </a:p>
-          <a:p>
-            <a:pPr lvl="1">
-              <a:spcAft>
-                <a:spcPts val="700"/>
-              </a:spcAft>
-              <a:defRPr sz="1100" b="0">
-                <a:solidFill>
-                  <a:srgbClr val="262B33"/>
-                </a:solidFill>
-              </a:defRPr>
-            </a:pPr>
-            <a:r>
-              <a:t>–  DM, VS, LB, EG, AE, CM, MH, IE, SV</a:t>
-            </a:r>
-          </a:p>
-          <a:p>
-            <a:pPr>
-              <a:spcAft>
-                <a:spcPts val="700"/>
-              </a:spcAft>
-              <a:defRPr sz="1300" b="1">
-                <a:solidFill>
-                  <a:srgbClr val="1F3A5F"/>
-                </a:solidFill>
-              </a:defRPr>
-            </a:pPr>
-            <a:r>
-              <a:t>•  Harder (being honest)</a:t>
-            </a:r>
-          </a:p>
-          <a:p>
-            <a:pPr lvl="1">
-              <a:spcAft>
-                <a:spcPts val="700"/>
-              </a:spcAft>
-              <a:defRPr sz="1100" b="0">
-                <a:solidFill>
-                  <a:srgbClr val="262B33"/>
-                </a:solidFill>
-              </a:defRPr>
-            </a:pPr>
-            <a:r>
-              <a:t>–  Novel field wording</a:t>
-            </a:r>
-          </a:p>
-          <a:p>
-            <a:pPr lvl="1">
-              <a:spcAft>
-                <a:spcPts val="700"/>
-              </a:spcAft>
-              <a:defRPr sz="1100" b="0">
-                <a:solidFill>
-                  <a:srgbClr val="262B33"/>
-                </a:solidFill>
-              </a:defRPr>
-            </a:pPr>
-            <a:r>
-              <a:t>–  Complex skip-logic forms</a:t>
-            </a:r>
-          </a:p>
-          <a:p>
-            <a:pPr lvl="1">
-              <a:spcAft>
-                <a:spcPts val="700"/>
-              </a:spcAft>
-              <a:defRPr sz="1100" b="0">
-                <a:solidFill>
-                  <a:srgbClr val="262B33"/>
-                </a:solidFill>
-              </a:defRPr>
-            </a:pPr>
-            <a:r>
-              <a:t>–  Study-specific questionnaires</a:t>
-            </a:r>
-          </a:p>
-          <a:p>
-            <a:pPr lvl="1">
-              <a:spcAft>
-                <a:spcPts val="700"/>
-              </a:spcAft>
-              <a:defRPr sz="1100" b="0">
-                <a:solidFill>
-                  <a:srgbClr val="262B33"/>
-                </a:solidFill>
-              </a:defRPr>
-            </a:pPr>
-            <a:r>
-              <a:t>–  Per-test grid fan-out</a:t>
-            </a:r>
-          </a:p>
-        </p:txBody>
-      </p:sp>
-      <p:sp>
-        <p:nvSpPr>
           <p:cNvPr id="6" name="TextBox 5"/>
           <p:cNvSpPr txBox="1"/>
           <p:nvPr/>
@@ -3690,7 +4752,7 @@
               </a:defRPr>
             </a:pPr>
             <a:r>
-              <a:t>What's next — LLM as a Tier-3 fallback</a:t>
+              <a:t>What's next — AI assist for the hard tail</a:t>
             </a:r>
           </a:p>
         </p:txBody>
@@ -3739,65 +4801,6 @@
           </a:p>
         </p:txBody>
       </p:sp>
-      <p:pic>
-        <p:nvPicPr>
-          <p:cNvPr id="4" name="Picture 3" descr="llm.png"/>
-          <p:cNvPicPr>
-            <a:picLocks noChangeAspect="1"/>
-          </p:cNvPicPr>
-          <p:nvPr/>
-        </p:nvPicPr>
-        <p:blipFill>
-          <a:blip r:embed="rId2"/>
-          <a:stretch>
-            <a:fillRect/>
-          </a:stretch>
-        </p:blipFill>
-        <p:spPr>
-          <a:xfrm>
-            <a:off x="457200" y="1234440"/>
-            <a:ext cx="11247120" cy="4817016"/>
-          </a:xfrm>
-          <a:prstGeom prst="rect">
-            <a:avLst/>
-          </a:prstGeom>
-        </p:spPr>
-      </p:pic>
-      <p:sp>
-        <p:nvSpPr>
-          <p:cNvPr id="5" name="TextBox 4"/>
-          <p:cNvSpPr txBox="1"/>
-          <p:nvPr/>
-        </p:nvSpPr>
-        <p:spPr>
-          <a:xfrm>
-            <a:off x="548640" y="5760720"/>
-            <a:ext cx="11155680" cy="822960"/>
-          </a:xfrm>
-          <a:prstGeom prst="rect">
-            <a:avLst/>
-          </a:prstGeom>
-          <a:noFill/>
-        </p:spPr>
-        <p:txBody>
-          <a:bodyPr wrap="square">
-            <a:spAutoFit/>
-          </a:bodyPr>
-          <a:lstStyle/>
-          <a:p>
-            <a:pPr>
-              <a:defRPr sz="1300">
-                <a:solidFill>
-                  <a:srgbClr val="262B33"/>
-                </a:solidFill>
-              </a:defRPr>
-            </a:pPr>
-            <a:r>
-              <a:t>Also on the roadmap: per-test grid fan-out · growing the rule library (config only, no code change) · always human-in-the-loop</a:t>
-            </a:r>
-          </a:p>
-        </p:txBody>
-      </p:sp>
       <p:sp>
         <p:nvSpPr>
           <p:cNvPr id="6" name="TextBox 5"/>
@@ -3868,6 +4871,30 @@
           </a:p>
         </p:txBody>
       </p:sp>
+      <p:pic>
+        <p:nvPicPr>
+          <p:cNvPr id="8" name="Picture 7" descr="s11_next.png"/>
+          <p:cNvPicPr>
+            <a:picLocks noChangeAspect="1"/>
+          </p:cNvPicPr>
+          <p:nvPr/>
+        </p:nvPicPr>
+        <p:blipFill>
+          <a:blip r:embed="rId3"/>
+          <a:stretch>
+            <a:fillRect/>
+          </a:stretch>
+        </p:blipFill>
+        <p:spPr>
+          <a:xfrm>
+            <a:off x="457200" y="1188720"/>
+            <a:ext cx="11247120" cy="4754880"/>
+          </a:xfrm>
+          <a:prstGeom prst="rect">
+            <a:avLst/>
+          </a:prstGeom>
+        </p:spPr>
+      </p:pic>
     </p:spTree>
   </p:cSld>
   <p:clrMapOvr>
@@ -3985,119 +5012,6 @@
       </p:sp>
       <p:sp>
         <p:nvSpPr>
-          <p:cNvPr id="4" name="TextBox 3"/>
-          <p:cNvSpPr txBox="1"/>
-          <p:nvPr/>
-        </p:nvSpPr>
-        <p:spPr>
-          <a:xfrm>
-            <a:off x="502920" y="1234440"/>
-            <a:ext cx="6675120" cy="4937760"/>
-          </a:xfrm>
-          <a:prstGeom prst="rect">
-            <a:avLst/>
-          </a:prstGeom>
-          <a:noFill/>
-        </p:spPr>
-        <p:txBody>
-          <a:bodyPr wrap="square">
-            <a:spAutoFit/>
-          </a:bodyPr>
-          <a:lstStyle/>
-          <a:p>
-            <a:pPr>
-              <a:spcAft>
-                <a:spcPts val="700"/>
-              </a:spcAft>
-              <a:defRPr sz="1550" b="1">
-                <a:solidFill>
-                  <a:srgbClr val="1F3A5F"/>
-                </a:solidFill>
-              </a:defRPr>
-            </a:pPr>
-            <a:r>
-              <a:t>•  A working first-draft aCRF generator: automates the repetitive ~80%, leaves judgement to the expert</a:t>
-            </a:r>
-          </a:p>
-          <a:p>
-            <a:pPr>
-              <a:spcAft>
-                <a:spcPts val="700"/>
-              </a:spcAft>
-              <a:defRPr sz="1550" b="1">
-                <a:solidFill>
-                  <a:srgbClr val="1F3A5F"/>
-                </a:solidFill>
-              </a:defRPr>
-            </a:pPr>
-            <a:r>
-              <a:t>•  Deterministic &amp; transparent — every annotation is explainable</a:t>
-            </a:r>
-          </a:p>
-          <a:p>
-            <a:pPr>
-              <a:spcAft>
-                <a:spcPts val="700"/>
-              </a:spcAft>
-              <a:defRPr sz="1550" b="1">
-                <a:solidFill>
-                  <a:srgbClr val="1F3A5F"/>
-                </a:solidFill>
-              </a:defRPr>
-            </a:pPr>
-            <a:r>
-              <a:t>•  Validation-friendly — real FreeText, searchable, Pinnacle-21 extractable, editable both ways</a:t>
-            </a:r>
-          </a:p>
-          <a:p>
-            <a:pPr>
-              <a:spcAft>
-                <a:spcPts val="700"/>
-              </a:spcAft>
-              <a:defRPr sz="1550" b="1">
-                <a:solidFill>
-                  <a:srgbClr val="1F3A5F"/>
-                </a:solidFill>
-              </a:defRPr>
-            </a:pPr>
-            <a:r>
-              <a:t>•  Generalises across EDC export styles, tested on 4 different CRFs</a:t>
-            </a:r>
-          </a:p>
-          <a:p>
-            <a:pPr>
-              <a:spcAft>
-                <a:spcPts val="700"/>
-              </a:spcAft>
-              <a:defRPr sz="1550" b="1">
-                <a:solidFill>
-                  <a:srgbClr val="1F3A5F"/>
-                </a:solidFill>
-              </a:defRPr>
-            </a:pPr>
-            <a:r>
-              <a:t>•  Grounded framing: a proof of concept and a starting point — not a replacement for review</a:t>
-            </a:r>
-          </a:p>
-          <a:p>
-            <a:pPr>
-              <a:spcAft>
-                <a:spcPts val="700"/>
-              </a:spcAft>
-              <a:defRPr sz="1550" b="1">
-                <a:solidFill>
-                  <a:srgbClr val="1F3A5F"/>
-                </a:solidFill>
-              </a:defRPr>
-            </a:pPr>
-            <a:r>
-              <a:t>•  Highest-leverage next step: wire the reserved LLM Tier-3 for the hard tail</a:t>
-            </a:r>
-          </a:p>
-        </p:txBody>
-      </p:sp>
-      <p:sp>
-        <p:nvSpPr>
           <p:cNvPr id="5" name="TextBox 4"/>
           <p:cNvSpPr txBox="1"/>
           <p:nvPr/>
@@ -4201,6 +5115,30 @@
           </a:p>
         </p:txBody>
       </p:sp>
+      <p:pic>
+        <p:nvPicPr>
+          <p:cNvPr id="8" name="Picture 7" descr="s12_takeaways.png"/>
+          <p:cNvPicPr>
+            <a:picLocks noChangeAspect="1"/>
+          </p:cNvPicPr>
+          <p:nvPr/>
+        </p:nvPicPr>
+        <p:blipFill>
+          <a:blip r:embed="rId2"/>
+          <a:stretch>
+            <a:fillRect/>
+          </a:stretch>
+        </p:blipFill>
+        <p:spPr>
+          <a:xfrm>
+            <a:off x="548640" y="1280160"/>
+            <a:ext cx="11091672" cy="3756857"/>
+          </a:xfrm>
+          <a:prstGeom prst="rect">
+            <a:avLst/>
+          </a:prstGeom>
+        </p:spPr>
+      </p:pic>
     </p:spTree>
   </p:cSld>
   <p:clrMapOvr>
@@ -4318,119 +5256,6 @@
       </p:sp>
       <p:sp>
         <p:nvSpPr>
-          <p:cNvPr id="4" name="TextBox 3"/>
-          <p:cNvSpPr txBox="1"/>
-          <p:nvPr/>
-        </p:nvSpPr>
-        <p:spPr>
-          <a:xfrm>
-            <a:off x="502920" y="1234440"/>
-            <a:ext cx="6675120" cy="4937760"/>
-          </a:xfrm>
-          <a:prstGeom prst="rect">
-            <a:avLst/>
-          </a:prstGeom>
-          <a:noFill/>
-        </p:spPr>
-        <p:txBody>
-          <a:bodyPr wrap="square">
-            <a:spAutoFit/>
-          </a:bodyPr>
-          <a:lstStyle/>
-          <a:p>
-            <a:pPr>
-              <a:spcAft>
-                <a:spcPts val="700"/>
-              </a:spcAft>
-              <a:defRPr sz="1600" b="1">
-                <a:solidFill>
-                  <a:srgbClr val="1F3A5F"/>
-                </a:solidFill>
-              </a:defRPr>
-            </a:pPr>
-            <a:r>
-              <a:t>•  Every study ships a blank CRF of ~500 pages that must be annotated by hand to SDTM</a:t>
-            </a:r>
-          </a:p>
-          <a:p>
-            <a:pPr lvl="1">
-              <a:spcAft>
-                <a:spcPts val="700"/>
-              </a:spcAft>
-              <a:defRPr sz="1400" b="0">
-                <a:solidFill>
-                  <a:srgbClr val="262B33"/>
-                </a:solidFill>
-              </a:defRPr>
-            </a:pPr>
-            <a:r>
-              <a:t>–  Slow — days to weeks of specialist effort per study</a:t>
-            </a:r>
-          </a:p>
-          <a:p>
-            <a:pPr lvl="1">
-              <a:spcAft>
-                <a:spcPts val="700"/>
-              </a:spcAft>
-              <a:defRPr sz="1400" b="0">
-                <a:solidFill>
-                  <a:srgbClr val="262B33"/>
-                </a:solidFill>
-              </a:defRPr>
-            </a:pPr>
-            <a:r>
-              <a:t>–  Repetitive — the same common mappings (DM, VS, LB, AE, CM…) are redone every study</a:t>
-            </a:r>
-          </a:p>
-          <a:p>
-            <a:pPr lvl="1">
-              <a:spcAft>
-                <a:spcPts val="700"/>
-              </a:spcAft>
-              <a:defRPr sz="1400" b="0">
-                <a:solidFill>
-                  <a:srgbClr val="262B33"/>
-                </a:solidFill>
-              </a:defRPr>
-            </a:pPr>
-            <a:r>
-              <a:t>–  Manual = easy to be inconsistent across pages and reviewers</a:t>
-            </a:r>
-          </a:p>
-          <a:p>
-            <a:pPr>
-              <a:spcAft>
-                <a:spcPts val="700"/>
-              </a:spcAft>
-              <a:defRPr sz="1600" b="1">
-                <a:solidFill>
-                  <a:srgbClr val="1F3A5F"/>
-                </a:solidFill>
-              </a:defRPr>
-            </a:pPr>
-            <a:r>
-              <a:t>•  The first ~80% is mechanical; the hard ~20% needs real judgement</a:t>
-            </a:r>
-          </a:p>
-          <a:p>
-            <a:pPr>
-              <a:spcAft>
-                <a:spcPts val="700"/>
-              </a:spcAft>
-              <a:defRPr sz="1600" b="1">
-                <a:solidFill>
-                  <a:srgbClr val="1F3A5F"/>
-                </a:solidFill>
-              </a:defRPr>
-            </a:pPr>
-            <a:r>
-              <a:t>•  Opportunity: auto-generate the mechanical first draft, free experts for the hard part</a:t>
-            </a:r>
-          </a:p>
-        </p:txBody>
-      </p:sp>
-      <p:sp>
-        <p:nvSpPr>
           <p:cNvPr id="5" name="TextBox 4"/>
           <p:cNvSpPr txBox="1"/>
           <p:nvPr/>
@@ -4499,6 +5324,30 @@
           </a:p>
         </p:txBody>
       </p:sp>
+      <p:pic>
+        <p:nvPicPr>
+          <p:cNvPr id="7" name="Picture 6" descr="s2_problem.png"/>
+          <p:cNvPicPr>
+            <a:picLocks noChangeAspect="1"/>
+          </p:cNvPicPr>
+          <p:nvPr/>
+        </p:nvPicPr>
+        <p:blipFill>
+          <a:blip r:embed="rId2"/>
+          <a:stretch>
+            <a:fillRect/>
+          </a:stretch>
+        </p:blipFill>
+        <p:spPr>
+          <a:xfrm>
+            <a:off x="548640" y="1234440"/>
+            <a:ext cx="11091672" cy="4830244"/>
+          </a:xfrm>
+          <a:prstGeom prst="rect">
+            <a:avLst/>
+          </a:prstGeom>
+        </p:spPr>
+      </p:pic>
     </p:spTree>
   </p:cSld>
   <p:clrMapOvr>
@@ -4616,119 +5465,6 @@
       </p:sp>
       <p:sp>
         <p:nvSpPr>
-          <p:cNvPr id="4" name="TextBox 3"/>
-          <p:cNvSpPr txBox="1"/>
-          <p:nvPr/>
-        </p:nvSpPr>
-        <p:spPr>
-          <a:xfrm>
-            <a:off x="502920" y="1234440"/>
-            <a:ext cx="6675120" cy="4937760"/>
-          </a:xfrm>
-          <a:prstGeom prst="rect">
-            <a:avLst/>
-          </a:prstGeom>
-          <a:noFill/>
-        </p:spPr>
-        <p:txBody>
-          <a:bodyPr wrap="square">
-            <a:spAutoFit/>
-          </a:bodyPr>
-          <a:lstStyle/>
-          <a:p>
-            <a:pPr>
-              <a:spcAft>
-                <a:spcPts val="700"/>
-              </a:spcAft>
-              <a:defRPr sz="1600" b="1">
-                <a:solidFill>
-                  <a:srgbClr val="1F3A5F"/>
-                </a:solidFill>
-              </a:defRPr>
-            </a:pPr>
-            <a:r>
-              <a:t>•  In:  a blank CRF PDF (AstraZeneca EDC export)</a:t>
-            </a:r>
-          </a:p>
-          <a:p>
-            <a:pPr>
-              <a:spcAft>
-                <a:spcPts val="700"/>
-              </a:spcAft>
-              <a:defRPr sz="1600" b="1">
-                <a:solidFill>
-                  <a:srgbClr val="1F3A5F"/>
-                </a:solidFill>
-              </a:defRPr>
-            </a:pPr>
-            <a:r>
-              <a:t>•  Out, in seconds:  a first-draft annotated CRF PDF</a:t>
-            </a:r>
-          </a:p>
-          <a:p>
-            <a:pPr lvl="1">
-              <a:spcAft>
-                <a:spcPts val="700"/>
-              </a:spcAft>
-              <a:defRPr sz="1400" b="0">
-                <a:solidFill>
-                  <a:srgbClr val="262B33"/>
-                </a:solidFill>
-              </a:defRPr>
-            </a:pPr>
-            <a:r>
-              <a:t>–  SDTM  DOMAIN.VARIABLE  placed in the right margin beside each field</a:t>
-            </a:r>
-          </a:p>
-          <a:p>
-            <a:pPr lvl="1">
-              <a:spcAft>
-                <a:spcPts val="700"/>
-              </a:spcAft>
-              <a:defRPr sz="1400" b="0">
-                <a:solidFill>
-                  <a:srgbClr val="262B33"/>
-                </a:solidFill>
-              </a:defRPr>
-            </a:pPr>
-            <a:r>
-              <a:t>–  Colour-coded by domain class · dual bookmarks · colour legend page</a:t>
-            </a:r>
-          </a:p>
-          <a:p>
-            <a:pPr>
-              <a:spcAft>
-                <a:spcPts val="700"/>
-              </a:spcAft>
-              <a:defRPr sz="1600" b="1">
-                <a:solidFill>
-                  <a:srgbClr val="1F3A5F"/>
-                </a:solidFill>
-              </a:defRPr>
-            </a:pPr>
-            <a:r>
-              <a:t>•  Deterministic &amp; transparent — every mapping is explainable, not a black box</a:t>
-            </a:r>
-          </a:p>
-          <a:p>
-            <a:pPr>
-              <a:spcAft>
-                <a:spcPts val="700"/>
-              </a:spcAft>
-              <a:defRPr sz="1600" b="1">
-                <a:solidFill>
-                  <a:srgbClr val="1F3A5F"/>
-                </a:solidFill>
-              </a:defRPr>
-            </a:pPr>
-            <a:r>
-              <a:t>•  Honest scope: a reviewed first draft, not a validated final aCRF</a:t>
-            </a:r>
-          </a:p>
-        </p:txBody>
-      </p:sp>
-      <p:sp>
-        <p:nvSpPr>
           <p:cNvPr id="5" name="TextBox 4"/>
           <p:cNvSpPr txBox="1"/>
           <p:nvPr/>
@@ -4797,6 +5533,30 @@
           </a:p>
         </p:txBody>
       </p:sp>
+      <p:pic>
+        <p:nvPicPr>
+          <p:cNvPr id="7" name="Picture 6" descr="s3_inout.png"/>
+          <p:cNvPicPr>
+            <a:picLocks noChangeAspect="1"/>
+          </p:cNvPicPr>
+          <p:nvPr/>
+        </p:nvPicPr>
+        <p:blipFill>
+          <a:blip r:embed="rId2"/>
+          <a:stretch>
+            <a:fillRect/>
+          </a:stretch>
+        </p:blipFill>
+        <p:spPr>
+          <a:xfrm>
+            <a:off x="640080" y="1234440"/>
+            <a:ext cx="10908792" cy="4649649"/>
+          </a:xfrm>
+          <a:prstGeom prst="rect">
+            <a:avLst/>
+          </a:prstGeom>
+        </p:spPr>
+      </p:pic>
     </p:spTree>
   </p:cSld>
   <p:clrMapOvr>
@@ -4912,83 +5672,6 @@
           </a:p>
         </p:txBody>
       </p:sp>
-      <p:pic>
-        <p:nvPicPr>
-          <p:cNvPr id="4" name="Picture 3" descr="pipeline.png"/>
-          <p:cNvPicPr>
-            <a:picLocks noChangeAspect="1"/>
-          </p:cNvPicPr>
-          <p:nvPr/>
-        </p:nvPicPr>
-        <p:blipFill>
-          <a:blip r:embed="rId2"/>
-          <a:stretch>
-            <a:fillRect/>
-          </a:stretch>
-        </p:blipFill>
-        <p:spPr>
-          <a:xfrm>
-            <a:off x="457200" y="1554480"/>
-            <a:ext cx="11247120" cy="2925809"/>
-          </a:xfrm>
-          <a:prstGeom prst="rect">
-            <a:avLst/>
-          </a:prstGeom>
-        </p:spPr>
-      </p:pic>
-      <p:sp>
-        <p:nvSpPr>
-          <p:cNvPr id="5" name="TextBox 4"/>
-          <p:cNvSpPr txBox="1"/>
-          <p:nvPr/>
-        </p:nvSpPr>
-        <p:spPr>
-          <a:xfrm>
-            <a:off x="548640" y="4572000"/>
-            <a:ext cx="10972800" cy="1371600"/>
-          </a:xfrm>
-          <a:prstGeom prst="rect">
-            <a:avLst/>
-          </a:prstGeom>
-          <a:noFill/>
-        </p:spPr>
-        <p:txBody>
-          <a:bodyPr wrap="square">
-            <a:spAutoFit/>
-          </a:bodyPr>
-          <a:lstStyle/>
-          <a:p>
-            <a:pPr>
-              <a:spcAft>
-                <a:spcPts val="600"/>
-              </a:spcAft>
-              <a:defRPr sz="1400">
-                <a:solidFill>
-                  <a:srgbClr val="262B33"/>
-                </a:solidFill>
-              </a:defRPr>
-            </a:pPr>
-            <a:r>
-              <a:t>•  Geometry-aware extraction reads fields even when the EDC prints no field numbers.</a:t>
-            </a:r>
-          </a:p>
-          <a:p>
-            <a:pPr>
-              <a:spcAft>
-                <a:spcPts val="600"/>
-              </a:spcAft>
-              <a:defRPr sz="1400">
-                <a:solidFill>
-                  <a:srgbClr val="262B33"/>
-                </a:solidFill>
-              </a:defRPr>
-            </a:pPr>
-            <a:r>
-              <a:t>•  Resolution is fully deterministic; annotations are written as real, searchable PDF FreeText objects.</a:t>
-            </a:r>
-          </a:p>
-        </p:txBody>
-      </p:sp>
       <p:sp>
         <p:nvSpPr>
           <p:cNvPr id="6" name="TextBox 5"/>
@@ -5059,6 +5742,30 @@
           </a:p>
         </p:txBody>
       </p:sp>
+      <p:pic>
+        <p:nvPicPr>
+          <p:cNvPr id="8" name="Picture 7" descr="s4_pipeline.png"/>
+          <p:cNvPicPr>
+            <a:picLocks noChangeAspect="1"/>
+          </p:cNvPicPr>
+          <p:nvPr/>
+        </p:nvPicPr>
+        <p:blipFill>
+          <a:blip r:embed="rId3"/>
+          <a:stretch>
+            <a:fillRect/>
+          </a:stretch>
+        </p:blipFill>
+        <p:spPr>
+          <a:xfrm>
+            <a:off x="457200" y="1920240"/>
+            <a:ext cx="11247120" cy="2743200"/>
+          </a:xfrm>
+          <a:prstGeom prst="rect">
+            <a:avLst/>
+          </a:prstGeom>
+        </p:spPr>
+      </p:pic>
     </p:spTree>
   </p:cSld>
   <p:clrMapOvr>
@@ -5125,7 +5832,7 @@
               </a:defRPr>
             </a:pPr>
             <a:r>
-              <a:t>Resolution engine — a deterministic cascade</a:t>
+              <a:t>Inside the SDTM mapping engine</a:t>
             </a:r>
           </a:p>
         </p:txBody>
@@ -5174,128 +5881,6 @@
           </a:p>
         </p:txBody>
       </p:sp>
-      <p:pic>
-        <p:nvPicPr>
-          <p:cNvPr id="4" name="Picture 3" descr="tiers.png"/>
-          <p:cNvPicPr>
-            <a:picLocks noChangeAspect="1"/>
-          </p:cNvPicPr>
-          <p:nvPr/>
-        </p:nvPicPr>
-        <p:blipFill>
-          <a:blip r:embed="rId2"/>
-          <a:stretch>
-            <a:fillRect/>
-          </a:stretch>
-        </p:blipFill>
-        <p:spPr>
-          <a:xfrm>
-            <a:off x="457200" y="1188720"/>
-            <a:ext cx="7680960" cy="4332136"/>
-          </a:xfrm>
-          <a:prstGeom prst="rect">
-            <a:avLst/>
-          </a:prstGeom>
-        </p:spPr>
-      </p:pic>
-      <p:sp>
-        <p:nvSpPr>
-          <p:cNvPr id="5" name="TextBox 4"/>
-          <p:cNvSpPr txBox="1"/>
-          <p:nvPr/>
-        </p:nvSpPr>
-        <p:spPr>
-          <a:xfrm>
-            <a:off x="8321040" y="1371600"/>
-            <a:ext cx="3657600" cy="4937760"/>
-          </a:xfrm>
-          <a:prstGeom prst="rect">
-            <a:avLst/>
-          </a:prstGeom>
-          <a:noFill/>
-        </p:spPr>
-        <p:txBody>
-          <a:bodyPr wrap="square">
-            <a:spAutoFit/>
-          </a:bodyPr>
-          <a:lstStyle/>
-          <a:p>
-            <a:pPr>
-              <a:spcAft>
-                <a:spcPts val="700"/>
-              </a:spcAft>
-              <a:defRPr sz="1200" b="1">
-                <a:solidFill>
-                  <a:srgbClr val="1F3A5F"/>
-                </a:solidFill>
-              </a:defRPr>
-            </a:pPr>
-            <a:r>
-              <a:t>•  Best-confidence match wins</a:t>
-            </a:r>
-          </a:p>
-          <a:p>
-            <a:pPr lvl="1">
-              <a:spcAft>
-                <a:spcPts val="700"/>
-              </a:spcAft>
-              <a:defRPr sz="1000" b="0">
-                <a:solidFill>
-                  <a:srgbClr val="262B33"/>
-                </a:solidFill>
-              </a:defRPr>
-            </a:pPr>
-            <a:r>
-              <a:t>–  High-confidence curated rules are never overridden</a:t>
-            </a:r>
-          </a:p>
-          <a:p>
-            <a:pPr lvl="1">
-              <a:spcAft>
-                <a:spcPts val="700"/>
-              </a:spcAft>
-              <a:defRPr sz="1000" b="0">
-                <a:solidFill>
-                  <a:srgbClr val="262B33"/>
-                </a:solidFill>
-              </a:defRPr>
-            </a:pPr>
-            <a:r>
-              <a:t>–  Passes 2–4 use CDISC standards + token similarity → a brand-new CRF still gets coverage</a:t>
-            </a:r>
-          </a:p>
-          <a:p>
-            <a:pPr>
-              <a:spcAft>
-                <a:spcPts val="700"/>
-              </a:spcAft>
-              <a:defRPr sz="1200" b="1">
-                <a:solidFill>
-                  <a:srgbClr val="1F3A5F"/>
-                </a:solidFill>
-              </a:defRPr>
-            </a:pPr>
-            <a:r>
-              <a:t>•  Deterministic = auditable &amp; reproducible (matters for GxP)</a:t>
-            </a:r>
-          </a:p>
-          <a:p>
-            <a:pPr>
-              <a:spcAft>
-                <a:spcPts val="700"/>
-              </a:spcAft>
-              <a:defRPr sz="1200" b="1">
-                <a:solidFill>
-                  <a:srgbClr val="1F3A5F"/>
-                </a:solidFill>
-              </a:defRPr>
-            </a:pPr>
-            <a:r>
-              <a:t>•  MedDRA / WHO-Drug / ATC coded fields are skipped before resolution</a:t>
-            </a:r>
-          </a:p>
-        </p:txBody>
-      </p:sp>
       <p:sp>
         <p:nvSpPr>
           <p:cNvPr id="6" name="TextBox 5"/>
@@ -5366,6 +5951,30 @@
           </a:p>
         </p:txBody>
       </p:sp>
+      <p:pic>
+        <p:nvPicPr>
+          <p:cNvPr id="8" name="Picture 7" descr="s5_engine.png"/>
+          <p:cNvPicPr>
+            <a:picLocks noChangeAspect="1"/>
+          </p:cNvPicPr>
+          <p:nvPr/>
+        </p:nvPicPr>
+        <p:blipFill>
+          <a:blip r:embed="rId3"/>
+          <a:stretch>
+            <a:fillRect/>
+          </a:stretch>
+        </p:blipFill>
+        <p:spPr>
+          <a:xfrm>
+            <a:off x="2011680" y="1234440"/>
+            <a:ext cx="8229600" cy="4643846"/>
+          </a:xfrm>
+          <a:prstGeom prst="rect">
+            <a:avLst/>
+          </a:prstGeom>
+        </p:spPr>
+      </p:pic>
     </p:spTree>
   </p:cSld>
   <p:clrMapOvr>
@@ -5432,7 +6041,7 @@
               </a:defRPr>
             </a:pPr>
             <a:r>
-              <a:t>Rules we engineered to (CDISC aCRF conventions)</a:t>
+              <a:t>Built to CDISC aCRF conventions</a:t>
             </a:r>
           </a:p>
         </p:txBody>
@@ -5483,134 +6092,6 @@
       </p:sp>
       <p:sp>
         <p:nvSpPr>
-          <p:cNvPr id="4" name="TextBox 3"/>
-          <p:cNvSpPr txBox="1"/>
-          <p:nvPr/>
-        </p:nvSpPr>
-        <p:spPr>
-          <a:xfrm>
-            <a:off x="502920" y="1234440"/>
-            <a:ext cx="6675120" cy="4937760"/>
-          </a:xfrm>
-          <a:prstGeom prst="rect">
-            <a:avLst/>
-          </a:prstGeom>
-          <a:noFill/>
-        </p:spPr>
-        <p:txBody>
-          <a:bodyPr wrap="square">
-            <a:spAutoFit/>
-          </a:bodyPr>
-          <a:lstStyle/>
-          <a:p>
-            <a:pPr>
-              <a:spcAft>
-                <a:spcPts val="700"/>
-              </a:spcAft>
-              <a:defRPr sz="1450" b="1">
-                <a:solidFill>
-                  <a:srgbClr val="1F3A5F"/>
-                </a:solidFill>
-              </a:defRPr>
-            </a:pPr>
-            <a:r>
-              <a:t>•  Every collected field → DOMAIN.VARIABLE, or [NOT SUBMITTED] if collected-but-unmapped</a:t>
-            </a:r>
-          </a:p>
-          <a:p>
-            <a:pPr>
-              <a:spcAft>
-                <a:spcPts val="700"/>
-              </a:spcAft>
-              <a:defRPr sz="1450" b="1">
-                <a:solidFill>
-                  <a:srgbClr val="1F3A5F"/>
-                </a:solidFill>
-              </a:defRPr>
-            </a:pPr>
-            <a:r>
-              <a:t>•  Derived fields skipped entirely — MedDRA / WHO-Drug / ATC codes &amp; dictionary text</a:t>
-            </a:r>
-          </a:p>
-          <a:p>
-            <a:pPr lvl="1">
-              <a:spcAft>
-                <a:spcPts val="700"/>
-              </a:spcAft>
-              <a:defRPr sz="1250" b="0">
-                <a:solidFill>
-                  <a:srgbClr val="262B33"/>
-                </a:solidFill>
-              </a:defRPr>
-            </a:pPr>
-            <a:r>
-              <a:t>–  (traceability for those lives in Define-XML, not the aCRF)</a:t>
-            </a:r>
-          </a:p>
-          <a:p>
-            <a:pPr lvl="1">
-              <a:spcAft>
-                <a:spcPts val="700"/>
-              </a:spcAft>
-              <a:defRPr sz="1250" b="0">
-                <a:solidFill>
-                  <a:srgbClr val="262B33"/>
-                </a:solidFill>
-              </a:defRPr>
-            </a:pPr>
-            <a:r>
-              <a:t>–  Free-text verbatim is annotated (AE.AETERM, CM.CMTRT…); its coded partner is skipped</a:t>
-            </a:r>
-          </a:p>
-          <a:p>
-            <a:pPr>
-              <a:spcAft>
-                <a:spcPts val="700"/>
-              </a:spcAft>
-              <a:defRPr sz="1450" b="1">
-                <a:solidFill>
-                  <a:srgbClr val="1F3A5F"/>
-                </a:solidFill>
-              </a:defRPr>
-            </a:pPr>
-            <a:r>
-              <a:t>•  Format: ALL CAPS · codelist in (Cxxxxx) · SUPP--.QVAL where QNAM · value-level where-clauses</a:t>
-            </a:r>
-          </a:p>
-          <a:p>
-            <a:pPr>
-              <a:spcAft>
-                <a:spcPts val="700"/>
-              </a:spcAft>
-              <a:defRPr sz="1450" b="1">
-                <a:solidFill>
-                  <a:srgbClr val="1F3A5F"/>
-                </a:solidFill>
-              </a:defRPr>
-            </a:pPr>
-            <a:r>
-              <a:t>•  Colour by domain class · dual bookmarks (by visit + by topic) · searchable text · legend page</a:t>
-            </a:r>
-          </a:p>
-          <a:p>
-            <a:pPr>
-              <a:spcAft>
-                <a:spcPts val="700"/>
-              </a:spcAft>
-              <a:defRPr sz="1450" b="1">
-                <a:solidFill>
-                  <a:srgbClr val="1F3A5F"/>
-                </a:solidFill>
-              </a:defRPr>
-            </a:pPr>
-            <a:r>
-              <a:t>•  NOT_SUBMITTED list = editable business logic (not a CDISC spec) — easy to extend</a:t>
-            </a:r>
-          </a:p>
-        </p:txBody>
-      </p:sp>
-      <p:sp>
-        <p:nvSpPr>
           <p:cNvPr id="5" name="TextBox 4"/>
           <p:cNvSpPr txBox="1"/>
           <p:nvPr/>
@@ -5679,6 +6160,30 @@
           </a:p>
         </p:txBody>
       </p:sp>
+      <p:pic>
+        <p:nvPicPr>
+          <p:cNvPr id="7" name="Picture 6" descr="s6_conventions.png"/>
+          <p:cNvPicPr>
+            <a:picLocks noChangeAspect="1"/>
+          </p:cNvPicPr>
+          <p:nvPr/>
+        </p:nvPicPr>
+        <p:blipFill>
+          <a:blip r:embed="rId2"/>
+          <a:stretch>
+            <a:fillRect/>
+          </a:stretch>
+        </p:blipFill>
+        <p:spPr>
+          <a:xfrm>
+            <a:off x="548640" y="1188720"/>
+            <a:ext cx="11091672" cy="4830244"/>
+          </a:xfrm>
+          <a:prstGeom prst="rect">
+            <a:avLst/>
+          </a:prstGeom>
+        </p:spPr>
+      </p:pic>
     </p:spTree>
   </p:cSld>
   <p:clrMapOvr>
@@ -6099,134 +6604,6 @@
       </p:sp>
       <p:sp>
         <p:nvSpPr>
-          <p:cNvPr id="4" name="TextBox 3"/>
-          <p:cNvSpPr txBox="1"/>
-          <p:nvPr/>
-        </p:nvSpPr>
-        <p:spPr>
-          <a:xfrm>
-            <a:off x="502920" y="1234440"/>
-            <a:ext cx="6675120" cy="4937760"/>
-          </a:xfrm>
-          <a:prstGeom prst="rect">
-            <a:avLst/>
-          </a:prstGeom>
-          <a:noFill/>
-        </p:spPr>
-        <p:txBody>
-          <a:bodyPr wrap="square">
-            <a:spAutoFit/>
-          </a:bodyPr>
-          <a:lstStyle/>
-          <a:p>
-            <a:pPr>
-              <a:spcAft>
-                <a:spcPts val="700"/>
-              </a:spcAft>
-              <a:defRPr sz="1550" b="1">
-                <a:solidFill>
-                  <a:srgbClr val="1F3A5F"/>
-                </a:solidFill>
-              </a:defRPr>
-            </a:pPr>
-            <a:r>
-              <a:t>•  Annotations are real PDF FreeText objects — not flattened images</a:t>
-            </a:r>
-          </a:p>
-          <a:p>
-            <a:pPr lvl="1">
-              <a:spcAft>
-                <a:spcPts val="700"/>
-              </a:spcAft>
-              <a:defRPr sz="1350" b="0">
-                <a:solidFill>
-                  <a:srgbClr val="262B33"/>
-                </a:solidFill>
-              </a:defRPr>
-            </a:pPr>
-            <a:r>
-              <a:t>–  Searchable (Ctrl+F) and selectable</a:t>
-            </a:r>
-          </a:p>
-          <a:p>
-            <a:pPr lvl="1">
-              <a:spcAft>
-                <a:spcPts val="700"/>
-              </a:spcAft>
-              <a:defRPr sz="1350" b="0">
-                <a:solidFill>
-                  <a:srgbClr val="262B33"/>
-                </a:solidFill>
-              </a:defRPr>
-            </a:pPr>
-            <a:r>
-              <a:t>–  Extractable by Pinnacle 21 — the industry-standard aCRF validation tool</a:t>
-            </a:r>
-          </a:p>
-          <a:p>
-            <a:pPr>
-              <a:spcAft>
-                <a:spcPts val="700"/>
-              </a:spcAft>
-              <a:defRPr sz="1550" b="1">
-                <a:solidFill>
-                  <a:srgbClr val="1F3A5F"/>
-                </a:solidFill>
-              </a:defRPr>
-            </a:pPr>
-            <a:r>
-              <a:t>•  Editable in BOTH directions</a:t>
-            </a:r>
-          </a:p>
-          <a:p>
-            <a:pPr lvl="1">
-              <a:spcAft>
-                <a:spcPts val="700"/>
-              </a:spcAft>
-              <a:defRPr sz="1350" b="0">
-                <a:solidFill>
-                  <a:srgbClr val="262B33"/>
-                </a:solidFill>
-              </a:defRPr>
-            </a:pPr>
-            <a:r>
-              <a:t>–  In the review frontend (edit a mapping, regenerate)</a:t>
-            </a:r>
-          </a:p>
-          <a:p>
-            <a:pPr lvl="1">
-              <a:spcAft>
-                <a:spcPts val="700"/>
-              </a:spcAft>
-              <a:defRPr sz="1350" b="0">
-                <a:solidFill>
-                  <a:srgbClr val="262B33"/>
-                </a:solidFill>
-              </a:defRPr>
-            </a:pPr>
-            <a:r>
-              <a:t>–  Directly in the output PDF (e.g. Adobe) — same as a hand-annotated aCRF</a:t>
-            </a:r>
-          </a:p>
-          <a:p>
-            <a:pPr>
-              <a:spcAft>
-                <a:spcPts val="700"/>
-              </a:spcAft>
-              <a:defRPr sz="1550" b="1">
-                <a:solidFill>
-                  <a:srgbClr val="1F3A5F"/>
-                </a:solidFill>
-              </a:defRPr>
-            </a:pPr>
-            <a:r>
-              <a:t>•  Why it matters: drops into the existing QC / validation workflow with no friction</a:t>
-            </a:r>
-          </a:p>
-        </p:txBody>
-      </p:sp>
-      <p:sp>
-        <p:nvSpPr>
           <p:cNvPr id="5" name="TextBox 4"/>
           <p:cNvSpPr txBox="1"/>
           <p:nvPr/>
@@ -6295,6 +6672,30 @@
           </a:p>
         </p:txBody>
       </p:sp>
+      <p:pic>
+        <p:nvPicPr>
+          <p:cNvPr id="7" name="Picture 6" descr="s8_freetext.png"/>
+          <p:cNvPicPr>
+            <a:picLocks noChangeAspect="1"/>
+          </p:cNvPicPr>
+          <p:nvPr/>
+        </p:nvPicPr>
+        <p:blipFill>
+          <a:blip r:embed="rId2"/>
+          <a:stretch>
+            <a:fillRect/>
+          </a:stretch>
+        </p:blipFill>
+        <p:spPr>
+          <a:xfrm>
+            <a:off x="548640" y="1325880"/>
+            <a:ext cx="11091672" cy="4472448"/>
+          </a:xfrm>
+          <a:prstGeom prst="rect">
+            <a:avLst/>
+          </a:prstGeom>
+        </p:spPr>
+      </p:pic>
     </p:spTree>
   </p:cSld>
   <p:clrMapOvr>
@@ -6412,134 +6813,6 @@
       </p:sp>
       <p:sp>
         <p:nvSpPr>
-          <p:cNvPr id="4" name="TextBox 3"/>
-          <p:cNvSpPr txBox="1"/>
-          <p:nvPr/>
-        </p:nvSpPr>
-        <p:spPr>
-          <a:xfrm>
-            <a:off x="502920" y="1234440"/>
-            <a:ext cx="6675120" cy="4937760"/>
-          </a:xfrm>
-          <a:prstGeom prst="rect">
-            <a:avLst/>
-          </a:prstGeom>
-          <a:noFill/>
-        </p:spPr>
-        <p:txBody>
-          <a:bodyPr wrap="square">
-            <a:spAutoFit/>
-          </a:bodyPr>
-          <a:lstStyle/>
-          <a:p>
-            <a:pPr>
-              <a:spcAft>
-                <a:spcPts val="700"/>
-              </a:spcAft>
-              <a:defRPr sz="1500" b="1">
-                <a:solidFill>
-                  <a:srgbClr val="1F3A5F"/>
-                </a:solidFill>
-              </a:defRPr>
-            </a:pPr>
-            <a:r>
-              <a:t>•  Handles 4+ study-ID header formats + a 'Project Name:' fallback for UAT/preview builds</a:t>
-            </a:r>
-          </a:p>
-          <a:p>
-            <a:pPr>
-              <a:spcAft>
-                <a:spcPts val="700"/>
-              </a:spcAft>
-              <a:defRPr sz="1500" b="1">
-                <a:solidFill>
-                  <a:srgbClr val="1F3A5F"/>
-                </a:solidFill>
-              </a:defRPr>
-            </a:pPr>
-            <a:r>
-              <a:t>•  Recovers a form code from the form NAME when the EDC omits it (30+ patterns)</a:t>
-            </a:r>
-          </a:p>
-          <a:p>
-            <a:pPr>
-              <a:spcAft>
-                <a:spcPts val="700"/>
-              </a:spcAft>
-              <a:defRPr sz="1500" b="1">
-                <a:solidFill>
-                  <a:srgbClr val="1F3A5F"/>
-                </a:solidFill>
-              </a:defRPr>
-            </a:pPr>
-            <a:r>
-              <a:t>•  Domain inference from codes, suffixes (VS1), underscores (LB_HEM), variants (DEM→DM) — never empty</a:t>
-            </a:r>
-          </a:p>
-          <a:p>
-            <a:pPr>
-              <a:spcAft>
-                <a:spcPts val="700"/>
-              </a:spcAft>
-              <a:defRPr sz="1500" b="1">
-                <a:solidFill>
-                  <a:srgbClr val="1F3A5F"/>
-                </a:solidFill>
-              </a:defRPr>
-            </a:pPr>
-            <a:r>
-              <a:t>•  Built CRF-first / study-agnostic — an important distinction:</a:t>
-            </a:r>
-          </a:p>
-          <a:p>
-            <a:pPr lvl="1">
-              <a:spcAft>
-                <a:spcPts val="700"/>
-              </a:spcAft>
-              <a:defRPr sz="1300" b="1">
-                <a:solidFill>
-                  <a:srgbClr val="1F3A5F"/>
-                </a:solidFill>
-              </a:defRPr>
-            </a:pPr>
-            <a:r>
-              <a:t>–  A generic EDC CRF flows INTO this tool</a:t>
-            </a:r>
-          </a:p>
-          <a:p>
-            <a:pPr lvl="1">
-              <a:spcAft>
-                <a:spcPts val="700"/>
-              </a:spcAft>
-              <a:defRPr sz="1300" b="1">
-                <a:solidFill>
-                  <a:srgbClr val="1F3A5F"/>
-                </a:solidFill>
-              </a:defRPr>
-            </a:pPr>
-            <a:r>
-              <a:t>–  …but a tool hard-wired to ONE EDC's export format would NOT generalise back to arbitrary CRFs</a:t>
-            </a:r>
-          </a:p>
-          <a:p>
-            <a:pPr>
-              <a:spcAft>
-                <a:spcPts val="700"/>
-              </a:spcAft>
-              <a:defRPr sz="1500" b="0">
-                <a:solidFill>
-                  <a:srgbClr val="262B33"/>
-                </a:solidFill>
-              </a:defRPr>
-            </a:pPr>
-            <a:r>
-              <a:t>•  Tested on 4 different blank CRFs to check coverage, not just one</a:t>
-            </a:r>
-          </a:p>
-        </p:txBody>
-      </p:sp>
-      <p:sp>
-        <p:nvSpPr>
           <p:cNvPr id="5" name="TextBox 4"/>
           <p:cNvSpPr txBox="1"/>
           <p:nvPr/>
@@ -6608,6 +6881,30 @@
           </a:p>
         </p:txBody>
       </p:sp>
+      <p:pic>
+        <p:nvPicPr>
+          <p:cNvPr id="7" name="Picture 6" descr="s9_edc.png"/>
+          <p:cNvPicPr>
+            <a:picLocks noChangeAspect="1"/>
+          </p:cNvPicPr>
+          <p:nvPr/>
+        </p:nvPicPr>
+        <p:blipFill>
+          <a:blip r:embed="rId2"/>
+          <a:stretch>
+            <a:fillRect/>
+          </a:stretch>
+        </p:blipFill>
+        <p:spPr>
+          <a:xfrm>
+            <a:off x="548640" y="1234440"/>
+            <a:ext cx="11091672" cy="4651346"/>
+          </a:xfrm>
+          <a:prstGeom prst="rect">
+            <a:avLst/>
+          </a:prstGeom>
+        </p:spPr>
+      </p:pic>
     </p:spTree>
   </p:cSld>
   <p:clrMapOvr>
@@ -6934,4 +7231,324 @@
   </a:objectDefaults>
   <a:extraClrSchemeLst/>
 </a:theme>
+</file>
+
+<file path=ppt/theme/theme2.xml><?xml version="1.0" encoding="utf-8"?>
+<a:theme xmlns:a="http://schemas.openxmlformats.org/drawingml/2006/main" name="Office Theme">
+  <a:themeElements>
+    <a:clrScheme name="Office">
+      <a:dk1>
+        <a:sysClr val="windowText" lastClr="000000"/>
+      </a:dk1>
+      <a:lt1>
+        <a:sysClr val="window" lastClr="FFFFFF"/>
+      </a:lt1>
+      <a:dk2>
+        <a:srgbClr val="1F497D"/>
+      </a:dk2>
+      <a:lt2>
+        <a:srgbClr val="EEECE1"/>
+      </a:lt2>
+      <a:accent1>
+        <a:srgbClr val="4F81BD"/>
+      </a:accent1>
+      <a:accent2>
+        <a:srgbClr val="C0504D"/>
+      </a:accent2>
+      <a:accent3>
+        <a:srgbClr val="9BBB59"/>
+      </a:accent3>
+      <a:accent4>
+        <a:srgbClr val="8064A2"/>
+      </a:accent4>
+      <a:accent5>
+        <a:srgbClr val="4BACC6"/>
+      </a:accent5>
+      <a:accent6>
+        <a:srgbClr val="F79646"/>
+      </a:accent6>
+      <a:hlink>
+        <a:srgbClr val="0000FF"/>
+      </a:hlink>
+      <a:folHlink>
+        <a:srgbClr val="800080"/>
+      </a:folHlink>
+    </a:clrScheme>
+    <a:fontScheme name="Office">
+      <a:majorFont>
+        <a:latin typeface="Calibri"/>
+        <a:ea typeface=""/>
+        <a:cs typeface=""/>
+        <a:font script="Jpan" typeface="ＭＳ Ｐゴシック"/>
+        <a:font script="Hang" typeface="맑은 고딕"/>
+        <a:font script="Hans" typeface="宋体"/>
+        <a:font script="Hant" typeface="新細明體"/>
+        <a:font script="Arab" typeface="Times New Roman"/>
+        <a:font script="Hebr" typeface="Times New Roman"/>
+        <a:font script="Thai" typeface="Angsana New"/>
+        <a:font script="Ethi" typeface="Nyala"/>
+        <a:font script="Beng" typeface="Vrinda"/>
+        <a:font script="Gujr" typeface="Shruti"/>
+        <a:font script="Khmr" typeface="MoolBoran"/>
+        <a:font script="Knda" typeface="Tunga"/>
+        <a:font script="Guru" typeface="Raavi"/>
+        <a:font script="Cans" typeface="Euphemia"/>
+        <a:font script="Cher" typeface="Plantagenet Cherokee"/>
+        <a:font script="Yiii" typeface="Microsoft Yi Baiti"/>
+        <a:font script="Tibt" typeface="Microsoft Himalaya"/>
+        <a:font script="Thaa" typeface="MV Boli"/>
+        <a:font script="Deva" typeface="Mangal"/>
+        <a:font script="Telu" typeface="Gautami"/>
+        <a:font script="Taml" typeface="Latha"/>
+        <a:font script="Syrc" typeface="Estrangelo Edessa"/>
+        <a:font script="Orya" typeface="Kalinga"/>
+        <a:font script="Mlym" typeface="Kartika"/>
+        <a:font script="Laoo" typeface="DokChampa"/>
+        <a:font script="Sinh" typeface="Iskoola Pota"/>
+        <a:font script="Mong" typeface="Mongolian Baiti"/>
+        <a:font script="Viet" typeface="Times New Roman"/>
+        <a:font script="Uigh" typeface="Microsoft Uighur"/>
+        <a:font script="Geor" typeface="Sylfaen"/>
+      </a:majorFont>
+      <a:minorFont>
+        <a:latin typeface="Calibri"/>
+        <a:ea typeface=""/>
+        <a:cs typeface=""/>
+        <a:font script="Jpan" typeface="ＭＳ Ｐゴシック"/>
+        <a:font script="Hang" typeface="맑은 고딕"/>
+        <a:font script="Hans" typeface="宋体"/>
+        <a:font script="Hant" typeface="新細明體"/>
+        <a:font script="Arab" typeface="Arial"/>
+        <a:font script="Hebr" typeface="Arial"/>
+        <a:font script="Thai" typeface="Cordia New"/>
+        <a:font script="Ethi" typeface="Nyala"/>
+        <a:font script="Beng" typeface="Vrinda"/>
+        <a:font script="Gujr" typeface="Shruti"/>
+        <a:font script="Khmr" typeface="DaunPenh"/>
+        <a:font script="Knda" typeface="Tunga"/>
+        <a:font script="Guru" typeface="Raavi"/>
+        <a:font script="Cans" typeface="Euphemia"/>
+        <a:font script="Cher" typeface="Plantagenet Cherokee"/>
+        <a:font script="Yiii" typeface="Microsoft Yi Baiti"/>
+        <a:font script="Tibt" typeface="Microsoft Himalaya"/>
+        <a:font script="Thaa" typeface="MV Boli"/>
+        <a:font script="Deva" typeface="Mangal"/>
+        <a:font script="Telu" typeface="Gautami"/>
+        <a:font script="Taml" typeface="Latha"/>
+        <a:font script="Syrc" typeface="Estrangelo Edessa"/>
+        <a:font script="Orya" typeface="Kalinga"/>
+        <a:font script="Mlym" typeface="Kartika"/>
+        <a:font script="Laoo" typeface="DokChampa"/>
+        <a:font script="Sinh" typeface="Iskoola Pota"/>
+        <a:font script="Mong" typeface="Mongolian Baiti"/>
+        <a:font script="Viet" typeface="Arial"/>
+        <a:font script="Uigh" typeface="Microsoft Uighur"/>
+        <a:font script="Geor" typeface="Sylfaen"/>
+      </a:minorFont>
+    </a:fontScheme>
+    <a:fmtScheme name="Office">
+      <a:fillStyleLst>
+        <a:solidFill>
+          <a:schemeClr val="phClr"/>
+        </a:solidFill>
+        <a:gradFill rotWithShape="1">
+          <a:gsLst>
+            <a:gs pos="0">
+              <a:schemeClr val="phClr">
+                <a:tint val="50000"/>
+                <a:satMod val="300000"/>
+              </a:schemeClr>
+            </a:gs>
+            <a:gs pos="35000">
+              <a:schemeClr val="phClr">
+                <a:tint val="37000"/>
+                <a:satMod val="300000"/>
+              </a:schemeClr>
+            </a:gs>
+            <a:gs pos="100000">
+              <a:schemeClr val="phClr">
+                <a:tint val="15000"/>
+                <a:satMod val="350000"/>
+              </a:schemeClr>
+            </a:gs>
+          </a:gsLst>
+          <a:lin ang="16200000" scaled="1"/>
+        </a:gradFill>
+        <a:gradFill rotWithShape="1">
+          <a:gsLst>
+            <a:gs pos="0">
+              <a:schemeClr val="phClr">
+                <a:tint val="100000"/>
+                <a:shade val="100000"/>
+                <a:satMod val="130000"/>
+              </a:schemeClr>
+            </a:gs>
+            <a:gs pos="100000">
+              <a:schemeClr val="phClr">
+                <a:tint val="50000"/>
+                <a:shade val="100000"/>
+                <a:satMod val="350000"/>
+              </a:schemeClr>
+            </a:gs>
+          </a:gsLst>
+          <a:lin ang="16200000" scaled="0"/>
+        </a:gradFill>
+      </a:fillStyleLst>
+      <a:lnStyleLst>
+        <a:ln w="9525" cap="flat" cmpd="sng" algn="ctr">
+          <a:solidFill>
+            <a:schemeClr val="phClr">
+              <a:shade val="95000"/>
+              <a:satMod val="105000"/>
+            </a:schemeClr>
+          </a:solidFill>
+          <a:prstDash val="solid"/>
+        </a:ln>
+        <a:ln w="25400" cap="flat" cmpd="sng" algn="ctr">
+          <a:solidFill>
+            <a:schemeClr val="phClr"/>
+          </a:solidFill>
+          <a:prstDash val="solid"/>
+        </a:ln>
+        <a:ln w="38100" cap="flat" cmpd="sng" algn="ctr">
+          <a:solidFill>
+            <a:schemeClr val="phClr"/>
+          </a:solidFill>
+          <a:prstDash val="solid"/>
+        </a:ln>
+      </a:lnStyleLst>
+      <a:effectStyleLst>
+        <a:effectStyle>
+          <a:effectLst>
+            <a:outerShdw blurRad="40000" dist="20000" dir="5400000" rotWithShape="0">
+              <a:srgbClr val="000000">
+                <a:alpha val="38000"/>
+              </a:srgbClr>
+            </a:outerShdw>
+          </a:effectLst>
+        </a:effectStyle>
+        <a:effectStyle>
+          <a:effectLst>
+            <a:outerShdw blurRad="40000" dist="23000" dir="5400000" rotWithShape="0">
+              <a:srgbClr val="000000">
+                <a:alpha val="35000"/>
+              </a:srgbClr>
+            </a:outerShdw>
+          </a:effectLst>
+        </a:effectStyle>
+        <a:effectStyle>
+          <a:effectLst>
+            <a:outerShdw blurRad="40000" dist="23000" dir="5400000" rotWithShape="0">
+              <a:srgbClr val="000000">
+                <a:alpha val="35000"/>
+              </a:srgbClr>
+            </a:outerShdw>
+          </a:effectLst>
+          <a:scene3d>
+            <a:camera prst="orthographicFront">
+              <a:rot lat="0" lon="0" rev="0"/>
+            </a:camera>
+            <a:lightRig rig="threePt" dir="t">
+              <a:rot lat="0" lon="0" rev="1200000"/>
+            </a:lightRig>
+          </a:scene3d>
+          <a:sp3d>
+            <a:bevelT w="63500" h="25400"/>
+          </a:sp3d>
+        </a:effectStyle>
+      </a:effectStyleLst>
+      <a:bgFillStyleLst>
+        <a:solidFill>
+          <a:schemeClr val="phClr"/>
+        </a:solidFill>
+        <a:gradFill rotWithShape="1">
+          <a:gsLst>
+            <a:gs pos="0">
+              <a:schemeClr val="phClr">
+                <a:tint val="40000"/>
+                <a:satMod val="350000"/>
+              </a:schemeClr>
+            </a:gs>
+            <a:gs pos="40000">
+              <a:schemeClr val="phClr">
+                <a:tint val="45000"/>
+                <a:shade val="99000"/>
+                <a:satMod val="350000"/>
+              </a:schemeClr>
+            </a:gs>
+            <a:gs pos="100000">
+              <a:schemeClr val="phClr">
+                <a:shade val="20000"/>
+                <a:satMod val="255000"/>
+              </a:schemeClr>
+            </a:gs>
+          </a:gsLst>
+          <a:path path="circle">
+            <a:fillToRect l="50000" t="-80000" r="50000" b="180000"/>
+          </a:path>
+        </a:gradFill>
+        <a:gradFill rotWithShape="1">
+          <a:gsLst>
+            <a:gs pos="0">
+              <a:schemeClr val="phClr">
+                <a:tint val="80000"/>
+                <a:satMod val="300000"/>
+              </a:schemeClr>
+            </a:gs>
+            <a:gs pos="100000">
+              <a:schemeClr val="phClr">
+                <a:shade val="30000"/>
+                <a:satMod val="200000"/>
+              </a:schemeClr>
+            </a:gs>
+          </a:gsLst>
+          <a:path path="circle">
+            <a:fillToRect l="50000" t="50000" r="50000" b="50000"/>
+          </a:path>
+        </a:gradFill>
+      </a:bgFillStyleLst>
+    </a:fmtScheme>
+  </a:themeElements>
+  <a:objectDefaults>
+    <a:spDef>
+      <a:spPr/>
+      <a:bodyPr/>
+      <a:lstStyle/>
+      <a:style>
+        <a:lnRef idx="1">
+          <a:schemeClr val="accent1"/>
+        </a:lnRef>
+        <a:fillRef idx="3">
+          <a:schemeClr val="accent1"/>
+        </a:fillRef>
+        <a:effectRef idx="2">
+          <a:schemeClr val="accent1"/>
+        </a:effectRef>
+        <a:fontRef idx="minor">
+          <a:schemeClr val="lt1"/>
+        </a:fontRef>
+      </a:style>
+    </a:spDef>
+    <a:lnDef>
+      <a:spPr/>
+      <a:bodyPr/>
+      <a:lstStyle/>
+      <a:style>
+        <a:lnRef idx="2">
+          <a:schemeClr val="accent1"/>
+        </a:lnRef>
+        <a:fillRef idx="0">
+          <a:schemeClr val="accent1"/>
+        </a:fillRef>
+        <a:effectRef idx="1">
+          <a:schemeClr val="accent1"/>
+        </a:effectRef>
+        <a:fontRef idx="minor">
+          <a:schemeClr val="tx1"/>
+        </a:fontRef>
+      </a:style>
+    </a:lnDef>
+  </a:objectDefaults>
+  <a:extraClrSchemeLst/>
+</a:theme>
 </file>
</xml_diff>

<commit_message>
Redesign deck as full-content visuals: keep all original content, render as infographics
</commit_message>
<xml_diff>
--- a/DEMO_new.pptx
+++ b/DEMO_new.pptx
@@ -513,7 +513,7 @@
           <a:lstStyle/>
           <a:p>
             <a:r>
-              <a:t>Intro. I'm an intern, and this is a proof-of-concept tool I built that auto-generates a first-draft annotated CRF (aCRF) from a blank CRF PDF. It does the repetitive ~80% of the annotation work; the SDTM programmer then reviews and finalises. I'm framing it as a helpful first draft and a starting point — not a replacement for our existing process.</a:t>
+              <a:t>I'm an intern; this is a proof-of-concept tool I built that generates a first-draft annotated CRF from a blank CRF PDF. It does the repetitive ~80%; the SDTM programmer reviews and finalises. A helpful first draft and a starting point, not a replacement for our process.</a:t>
             </a:r>
           </a:p>
         </p:txBody>
@@ -583,7 +583,7 @@
           <a:lstStyle/>
           <a:p>
             <a:r>
-              <a:t>First-draft coverage across 4 different CRFs and export styles: 87% (D9186, standard), 62% and 62% (UAT builds with codes stripped out), and 90% (D5180, 503 pages). Strongest domains: DM, VS, LB, EG, AE, CM, MH, IE, SV. Being honest, the harder cases are novel field wording, complex skip-logic forms, study-specific questionnaires, and per-test grid fan-out.</a:t>
+              <a:t>Coverage across 4 CRFs/export styles: 87% (D9186), 62% and 62% (UAT, codes stripped), 90% (D5180, 503pp). Strongest: DM, VS, LB, EG, AE, CM, MH, IE, SV. Harder: novel wording, skip-logic forms, study-specific questionnaires, per-test grid fan-out.</a:t>
             </a:r>
           </a:p>
         </p:txBody>
@@ -653,7 +653,7 @@
           <a:lstStyle/>
           <a:p>
             <a:r>
-              <a:t>The highest-leverage next step is an AI assist as a Tier-3 fallback for the ~10% hard tail. It would run only on unresolved or low-confidence fields, see the field label plus form context plus candidate variables, and propose a mapping with a confidence score — never overriding high-confidence mappings. Assist-only keeps the trustworthy core and adds reach on the long tail. Also on the roadmap: per-test grid fan-out and growing the knowledge library (config only, no code change). Human review is always in the loop.</a:t>
+              <a:t>Highest-leverage next step: LLM as a Tier-3 fallback for the ~10% hard tail - runs only on unresolved/low-confidence fields, sees label + form context + candidate variables, proposes a mapping + confidence, never overrides high-confidence matches. Roadmap: per-test grid fan-out, growing the knowledge library (config only). Human review always in the loop.</a:t>
             </a:r>
           </a:p>
         </p:txBody>
@@ -723,7 +723,7 @@
           <a:lstStyle/>
           <a:p>
             <a:r>
-              <a:t>To recap: it automates the repetitive ~80% and leaves judgement to the expert; it's explainable and transparent — every annotation is traceable; it's validation-friendly — searchable, Pinnacle-21 ready, editable both ways; it generalises across EDC export styles, tested on 4 CRFs; and it's a first draft and a starting point, not a replacement for review. Thank you — happy to take questions.</a:t>
+              <a:t>Recap: automates the repetitive ~80%; transparent and explainable; validation-friendly (real FreeText, searchable, Pinnacle-21, editable both ways); generalises across EDC styles, tested on 4 CRFs; a proof of concept and starting point, not a replacement for review. Next: wire the reserved LLM Tier-3. Thank you.</a:t>
             </a:r>
           </a:p>
         </p:txBody>
@@ -793,7 +793,7 @@
           <a:lstStyle/>
           <a:p>
             <a:r>
-              <a:t>Every study ships a blank CRF of roughly 500 pages that has to be annotated by hand to SDTM. It's slow (days to weeks of specialist effort per study), repetitive (the same common DM / VS / LB / AE / CM mappings are redone every study), and being manual it's easy to be inconsistent across pages and reviewers. The first ~80% is mechanical; the hard ~20% needs real judgement. The opportunity is to auto-generate the mechanical first draft and free experts for the hard part.</a:t>
+              <a:t>Real generated pages, not mockups. Left: Demographics - DM.SEX/RACE/ETHNIC + SUPPDM.QVAL. Right: a Findings page - VS.VSORRES with value-level where VSTESTCD per test.</a:t>
             </a:r>
           </a:p>
         </p:txBody>
@@ -863,7 +863,7 @@
           <a:lstStyle/>
           <a:p>
             <a:r>
-              <a:t>Input: a blank CRF PDF (an AstraZeneca EDC export). Output, in seconds: a first-draft annotated CRF PDF — the SDTM DOMAIN.VARIABLE placed in the right margin beside each field, colour-coded by domain class, with dual bookmarks and a colour legend page. Every mapping is explainable. Honest scope: this is a reviewed first draft, not a validated final aCRF.</a:t>
+              <a:t>Blank CRF ~500 pages annotated by hand to SDTM: slow (days-weeks), repetitive (same DM/VS/LB/AE/CM mappings each study), and manual work varies across pages/reviewers. First ~80% mechanical, hard ~20% needs judgement. Auto-generate the first draft, free experts for the hard part.</a:t>
             </a:r>
           </a:p>
         </p:txBody>
@@ -933,7 +933,7 @@
           <a:lstStyle/>
           <a:p>
             <a:r>
-              <a:t>The pipeline: read the blank CRF, locate every field (geometry-aware — it works even when the EDC prints no field numbers), map each field to SDTM, then annotate and bookmark. The annotations are written as real, searchable PDF text objects.</a:t>
+              <a:t>In: a blank CRF PDF (AZ EDC export). Out in seconds: a first-draft annotated CRF - DOMAIN.VARIABLE in the right margin by each field, colour-coded by domain, dual bookmarks, legend page. Transparent: every mapping is explainable. Honest scope: a reviewed first draft, not a validated final aCRF.</a:t>
             </a:r>
           </a:p>
         </p:txBody>
@@ -1003,7 +1003,7 @@
           <a:lstStyle/>
           <a:p>
             <a:r>
-              <a:t>Each field passes through confidence-ranked layers and the highest-confidence match wins. First a pre-filter skips derived and coded fields. Then: AZ + CDISC curated knowledge (highest confidence, ~0.98), CDISC SDTM standards match (~0.92), study-spec exact label match (~0.90), and study-spec similarity match (&lt;=0.86). High-confidence matches are never overridden. Because the later layers use CDISC standards and similarity, a brand-new CRF still gets meaningful coverage. MedDRA / WHO-Drug / ATC coded fields are skipped before mapping. Everything is auditable and reproducible — which matters for GxP.</a:t>
+              <a:t>Pipeline: read the blank CRF, locate every field (geometry-aware, works even with no field numbers), map to SDTM, annotate and bookmark. Mapping is fully explainable; annotations are real searchable PDF text.</a:t>
             </a:r>
           </a:p>
         </p:txBody>
@@ -1073,7 +1073,7 @@
           <a:lstStyle/>
           <a:p>
             <a:r>
-              <a:t>We follow CDISC aCRF conventions. Every collected field gets DOMAIN.VARIABLE, or [NOT SUBMITTED] if it's collected but unmapped. Derived and coded fields — MedDRA, WHO-Drug, ATC dictionary terms — are skipped entirely; their traceability lives in Define-XML. Verbatim free-text is annotated (AE.AETERM, CM.CMTRT...) while its coded partner is skipped. Format: ALL CAPS, codelist in (Cxxxxx), SUPP--.QVAL where QNAM, and value-level where-clauses. Colour by domain class, dual bookmarks (by visit and by topic), searchable text, and a legend page. The [NOT SUBMITTED] list is editable business logic, not a fixed spec, so it's easy to extend.</a:t>
+              <a:t>Confidence-ranked cascade, best match wins. Pre-filter skips derived/coded fields, then AZ+CDISC curated knowledge (~0.98), CDISC standards (~0.92), study-spec exact (~0.90), study-spec similarity (&lt;=0.86). High-confidence matches never overridden; standards+similarity give a new CRF coverage. MedDRA/WHO-Drug/ATC skipped before mapping. Auditable and reproducible - matters for GxP.</a:t>
             </a:r>
           </a:p>
         </p:txBody>
@@ -1143,7 +1143,7 @@
           <a:lstStyle/>
           <a:p>
             <a:r>
-              <a:t>These are real generated pages, not mockups. Left: Demographics — DM.SEX / DM.RACE / DM.ETHNIC, plus SUPPDM.QVAL for 'other race, specify'. Right: a Findings page — VS.VSORRES with value-level 'where VSTESTCD = ...' per test. This shows annotations placed next to the field, carrying the correct qualifiers.</a:t>
+              <a:t>CDISC aCRF conventions: every collected field gets DOMAIN.VARIABLE or [NOT SUBMITTED]. Derived/coded fields (MedDRA/WHO-Drug/ATC) skipped - traceability in Define-XML. Verbatim annotated (AE.AETERM, CM.CMTRT), coded partner skipped. Format ALL CAPS, (Cxxxxx), SUPP--.QVAL where QNAM, where-clauses. Colour by class, dual bookmarks, searchable, legend. [NOT SUBMITTED] is editable business logic.</a:t>
             </a:r>
           </a:p>
         </p:txBody>
@@ -1213,7 +1213,7 @@
           <a:lstStyle/>
           <a:p>
             <a:r>
-              <a:t>The annotations are real PDF text objects, not flattened images — so they're searchable (Ctrl+F), selectable, and extractable by Pinnacle 21, the industry-standard aCRF validation tool. They're editable both ways: in the review frontend (edit a mapping and regenerate) and directly in the output PDF (e.g. Adobe), exactly like a hand-annotated aCRF. So it drops into the existing QC / validation workflow with no friction.</a:t>
+              <a:t>Annotations are real PDF FreeText, not images - searchable (Ctrl+F), selectable, extractable by Pinnacle 21 (industry-standard validation). Editable both ways: review frontend (edit + regenerate) and in the output PDF (Adobe). Drops into the existing QC/validation workflow with no friction.</a:t>
             </a:r>
           </a:p>
         </p:txBody>
@@ -1283,7 +1283,7 @@
           <a:lstStyle/>
           <a:p>
             <a:r>
-              <a:t>Built CRF-first and study-agnostic. It handles 4+ study-ID header formats plus a 'Project Name:' fallback for UAT/preview builds, recovers a form code from the form name when the EDC omits it (30+ patterns), and infers the domain from codes, suffixes (VS1), underscores (LB_HEM) and variants (DEM to DM). Important distinction: any CRF flows into this tool, but a tool hard-wired to one EDC's export format would not generalise back to arbitrary CRFs. Tested on 4 different blank CRFs, not just one.</a:t>
+              <a:t>CRF-first/study-agnostic: 4+ study-ID header formats + Project Name fallback, recovers form code from form name (30+ patterns), domain inference (codes, suffixes, underscores, variants) - never empty. Any CRF flows in, but a tool hard-wired to one EDC wouldn't generalise back. Tested on 4 different CRFs.</a:t>
             </a:r>
           </a:p>
         </p:txBody>
@@ -4592,30 +4592,6 @@
           </a:p>
         </p:txBody>
       </p:sp>
-      <p:pic>
-        <p:nvPicPr>
-          <p:cNvPr id="4" name="Picture 3" descr="coverage.png"/>
-          <p:cNvPicPr>
-            <a:picLocks noChangeAspect="1"/>
-          </p:cNvPicPr>
-          <p:nvPr/>
-        </p:nvPicPr>
-        <p:blipFill>
-          <a:blip r:embed="rId2"/>
-          <a:stretch>
-            <a:fillRect/>
-          </a:stretch>
-        </p:blipFill>
-        <p:spPr>
-          <a:xfrm>
-            <a:off x="457200" y="1280160"/>
-            <a:ext cx="6400800" cy="3242790"/>
-          </a:xfrm>
-          <a:prstGeom prst="rect">
-            <a:avLst/>
-          </a:prstGeom>
-        </p:spPr>
-      </p:pic>
       <p:sp>
         <p:nvSpPr>
           <p:cNvPr id="6" name="TextBox 5"/>
@@ -4686,6 +4662,30 @@
           </a:p>
         </p:txBody>
       </p:sp>
+      <p:pic>
+        <p:nvPicPr>
+          <p:cNvPr id="8" name="Picture 7" descr="body10.png"/>
+          <p:cNvPicPr>
+            <a:picLocks noChangeAspect="1"/>
+          </p:cNvPicPr>
+          <p:nvPr/>
+        </p:nvPicPr>
+        <p:blipFill>
+          <a:blip r:embed="rId3"/>
+          <a:stretch>
+            <a:fillRect/>
+          </a:stretch>
+        </p:blipFill>
+        <p:spPr>
+          <a:xfrm>
+            <a:off x="274320" y="1078992"/>
+            <a:ext cx="11640312" cy="5229046"/>
+          </a:xfrm>
+          <a:prstGeom prst="rect">
+            <a:avLst/>
+          </a:prstGeom>
+        </p:spPr>
+      </p:pic>
     </p:spTree>
   </p:cSld>
   <p:clrMapOvr>
@@ -4752,7 +4752,7 @@
               </a:defRPr>
             </a:pPr>
             <a:r>
-              <a:t>What's next — AI assist for the hard tail</a:t>
+              <a:t>What's next — LLM as a Tier-3 fallback</a:t>
             </a:r>
           </a:p>
         </p:txBody>
@@ -4873,7 +4873,7 @@
       </p:sp>
       <p:pic>
         <p:nvPicPr>
-          <p:cNvPr id="8" name="Picture 7" descr="s11_next.png"/>
+          <p:cNvPr id="8" name="Picture 7" descr="body11.png"/>
           <p:cNvPicPr>
             <a:picLocks noChangeAspect="1"/>
           </p:cNvPicPr>
@@ -4887,8 +4887,8 @@
         </p:blipFill>
         <p:spPr>
           <a:xfrm>
-            <a:off x="457200" y="1188720"/>
-            <a:ext cx="11247120" cy="4754880"/>
+            <a:off x="274320" y="1078992"/>
+            <a:ext cx="11640312" cy="5229046"/>
           </a:xfrm>
           <a:prstGeom prst="rect">
             <a:avLst/>
@@ -5012,41 +5012,6 @@
       </p:sp>
       <p:sp>
         <p:nvSpPr>
-          <p:cNvPr id="5" name="TextBox 4"/>
-          <p:cNvSpPr txBox="1"/>
-          <p:nvPr/>
-        </p:nvSpPr>
-        <p:spPr>
-          <a:xfrm>
-            <a:off x="502920" y="5852160"/>
-            <a:ext cx="10058400" cy="548640"/>
-          </a:xfrm>
-          <a:prstGeom prst="rect">
-            <a:avLst/>
-          </a:prstGeom>
-          <a:noFill/>
-        </p:spPr>
-        <p:txBody>
-          <a:bodyPr wrap="none">
-            <a:spAutoFit/>
-          </a:bodyPr>
-          <a:lstStyle/>
-          <a:p>
-            <a:pPr>
-              <a:defRPr sz="1600" b="1">
-                <a:solidFill>
-                  <a:srgbClr val="2A9D8F"/>
-                </a:solidFill>
-              </a:defRPr>
-            </a:pPr>
-            <a:r>
-              <a:t>Thank you — questions welcome.</a:t>
-            </a:r>
-          </a:p>
-        </p:txBody>
-      </p:sp>
-      <p:sp>
-        <p:nvSpPr>
           <p:cNvPr id="6" name="TextBox 5"/>
           <p:cNvSpPr txBox="1"/>
           <p:nvPr/>
@@ -5117,7 +5082,7 @@
       </p:sp>
       <p:pic>
         <p:nvPicPr>
-          <p:cNvPr id="8" name="Picture 7" descr="s12_takeaways.png"/>
+          <p:cNvPr id="8" name="Picture 7" descr="body12.png"/>
           <p:cNvPicPr>
             <a:picLocks noChangeAspect="1"/>
           </p:cNvPicPr>
@@ -5131,8 +5096,8 @@
         </p:blipFill>
         <p:spPr>
           <a:xfrm>
-            <a:off x="548640" y="1280160"/>
-            <a:ext cx="11091672" cy="3756857"/>
+            <a:off x="274320" y="1078992"/>
+            <a:ext cx="11640312" cy="5229046"/>
           </a:xfrm>
           <a:prstGeom prst="rect">
             <a:avLst/>
@@ -5326,7 +5291,7 @@
       </p:sp>
       <p:pic>
         <p:nvPicPr>
-          <p:cNvPr id="7" name="Picture 6" descr="s2_problem.png"/>
+          <p:cNvPr id="7" name="Picture 6" descr="body2.png"/>
           <p:cNvPicPr>
             <a:picLocks noChangeAspect="1"/>
           </p:cNvPicPr>
@@ -5340,8 +5305,8 @@
         </p:blipFill>
         <p:spPr>
           <a:xfrm>
-            <a:off x="548640" y="1234440"/>
-            <a:ext cx="11091672" cy="4830244"/>
+            <a:off x="274320" y="1078992"/>
+            <a:ext cx="11640312" cy="5229046"/>
           </a:xfrm>
           <a:prstGeom prst="rect">
             <a:avLst/>
@@ -5535,7 +5500,7 @@
       </p:sp>
       <p:pic>
         <p:nvPicPr>
-          <p:cNvPr id="7" name="Picture 6" descr="s3_inout.png"/>
+          <p:cNvPr id="7" name="Picture 6" descr="body3.png"/>
           <p:cNvPicPr>
             <a:picLocks noChangeAspect="1"/>
           </p:cNvPicPr>
@@ -5549,8 +5514,8 @@
         </p:blipFill>
         <p:spPr>
           <a:xfrm>
-            <a:off x="640080" y="1234440"/>
-            <a:ext cx="10908792" cy="4649649"/>
+            <a:off x="274320" y="1078992"/>
+            <a:ext cx="11640312" cy="5229046"/>
           </a:xfrm>
           <a:prstGeom prst="rect">
             <a:avLst/>
@@ -5744,7 +5709,7 @@
       </p:sp>
       <p:pic>
         <p:nvPicPr>
-          <p:cNvPr id="8" name="Picture 7" descr="s4_pipeline.png"/>
+          <p:cNvPr id="8" name="Picture 7" descr="body4.png"/>
           <p:cNvPicPr>
             <a:picLocks noChangeAspect="1"/>
           </p:cNvPicPr>
@@ -5758,8 +5723,8 @@
         </p:blipFill>
         <p:spPr>
           <a:xfrm>
-            <a:off x="457200" y="1920240"/>
-            <a:ext cx="11247120" cy="2743200"/>
+            <a:off x="274320" y="1078992"/>
+            <a:ext cx="11640312" cy="5229046"/>
           </a:xfrm>
           <a:prstGeom prst="rect">
             <a:avLst/>
@@ -5832,7 +5797,7 @@
               </a:defRPr>
             </a:pPr>
             <a:r>
-              <a:t>Inside the SDTM mapping engine</a:t>
+              <a:t>SDTM mapping engine — a confidence-ranked cascade</a:t>
             </a:r>
           </a:p>
         </p:txBody>
@@ -5953,7 +5918,7 @@
       </p:sp>
       <p:pic>
         <p:nvPicPr>
-          <p:cNvPr id="8" name="Picture 7" descr="s5_engine.png"/>
+          <p:cNvPr id="8" name="Picture 7" descr="body5.png"/>
           <p:cNvPicPr>
             <a:picLocks noChangeAspect="1"/>
           </p:cNvPicPr>
@@ -5967,8 +5932,8 @@
         </p:blipFill>
         <p:spPr>
           <a:xfrm>
-            <a:off x="2011680" y="1234440"/>
-            <a:ext cx="8229600" cy="4643846"/>
+            <a:off x="274320" y="1078992"/>
+            <a:ext cx="11640312" cy="5229046"/>
           </a:xfrm>
           <a:prstGeom prst="rect">
             <a:avLst/>
@@ -6041,7 +6006,7 @@
               </a:defRPr>
             </a:pPr>
             <a:r>
-              <a:t>Built to CDISC aCRF conventions</a:t>
+              <a:t>Conventions we engineered to (CDISC aCRF)</a:t>
             </a:r>
           </a:p>
         </p:txBody>
@@ -6162,7 +6127,7 @@
       </p:sp>
       <p:pic>
         <p:nvPicPr>
-          <p:cNvPr id="7" name="Picture 6" descr="s6_conventions.png"/>
+          <p:cNvPr id="7" name="Picture 6" descr="body6.png"/>
           <p:cNvPicPr>
             <a:picLocks noChangeAspect="1"/>
           </p:cNvPicPr>
@@ -6176,8 +6141,8 @@
         </p:blipFill>
         <p:spPr>
           <a:xfrm>
-            <a:off x="548640" y="1188720"/>
-            <a:ext cx="11091672" cy="4830244"/>
+            <a:off x="274320" y="1078992"/>
+            <a:ext cx="11640312" cy="5229046"/>
           </a:xfrm>
           <a:prstGeom prst="rect">
             <a:avLst/>
@@ -6674,7 +6639,7 @@
       </p:sp>
       <p:pic>
         <p:nvPicPr>
-          <p:cNvPr id="7" name="Picture 6" descr="s8_freetext.png"/>
+          <p:cNvPr id="7" name="Picture 6" descr="body8.png"/>
           <p:cNvPicPr>
             <a:picLocks noChangeAspect="1"/>
           </p:cNvPicPr>
@@ -6688,8 +6653,8 @@
         </p:blipFill>
         <p:spPr>
           <a:xfrm>
-            <a:off x="548640" y="1325880"/>
-            <a:ext cx="11091672" cy="4472448"/>
+            <a:off x="274320" y="1078992"/>
+            <a:ext cx="11640312" cy="5229046"/>
           </a:xfrm>
           <a:prstGeom prst="rect">
             <a:avLst/>
@@ -6883,7 +6848,7 @@
       </p:sp>
       <p:pic>
         <p:nvPicPr>
-          <p:cNvPr id="7" name="Picture 6" descr="s9_edc.png"/>
+          <p:cNvPr id="7" name="Picture 6" descr="body9.png"/>
           <p:cNvPicPr>
             <a:picLocks noChangeAspect="1"/>
           </p:cNvPicPr>
@@ -6897,8 +6862,8 @@
         </p:blipFill>
         <p:spPr>
           <a:xfrm>
-            <a:off x="548640" y="1234440"/>
-            <a:ext cx="11091672" cy="4651346"/>
+            <a:off x="274320" y="1078992"/>
+            <a:ext cx="11640312" cy="5229046"/>
           </a:xfrm>
           <a:prstGeom prst="rect">
             <a:avLst/>

</xml_diff>